<commit_message>
feat: Add GCS upload and improve UploadZone UI
</commit_message>
<xml_diff>
--- a/docs/Local_Lens_Pitch_Deck.pptx
+++ b/docs/Local_Lens_Pitch_Deck.pptx
@@ -15,7 +15,7 @@
     <p:sldId id="263" r:id="rId14"/>
     <p:sldId id="264" r:id="rId15"/>
   </p:sldIdLst>
-  <p:sldSz cx="9144000" cy="6858000" type="screen4x3"/>
+  <p:sldSz cx="12191695" cy="6858000" type="screen4x3"/>
   <p:notesSz cx="6858000" cy="9144000"/>
   <p:defaultTextStyle>
     <a:defPPr>
@@ -3089,6 +3089,14 @@
 <file path=ppt/slides/slide1.xml><?xml version="1.0" encoding="utf-8"?>
 <p:sld xmlns:a="http://schemas.openxmlformats.org/drawingml/2006/main" xmlns:p="http://schemas.openxmlformats.org/presentationml/2006/main" xmlns:r="http://schemas.openxmlformats.org/officeDocument/2006/relationships">
   <p:cSld>
+    <p:bg>
+      <p:bgPr>
+        <a:solidFill>
+          <a:srgbClr val="0B0F19"/>
+        </a:solidFill>
+        <a:effectLst/>
+      </p:bgPr>
+    </p:bg>
     <p:spTree>
       <p:nvGrpSpPr>
         <p:cNvPr id="1" name=""/>
@@ -3098,25 +3106,204 @@
       <p:grpSpPr/>
       <p:sp>
         <p:nvSpPr>
-          <p:cNvPr id="2" name="Title 1"/>
-          <p:cNvSpPr>
-            <a:spLocks noGrp="1"/>
-          </p:cNvSpPr>
-          <p:nvPr>
-            <p:ph type="ctrTitle"/>
-          </p:nvPr>
-        </p:nvSpPr>
-        <p:spPr/>
-        <p:txBody>
-          <a:bodyPr/>
-          <a:lstStyle/>
-          <a:p>
-            <a:pPr>
-              <a:defRPr sz="4400" b="1">
-                <a:solidFill>
-                  <a:srgbClr val="4285F4"/>
-                </a:solidFill>
-                <a:latin typeface="Arial"/>
+          <p:cNvPr id="2" name="Rectangle 1"/>
+          <p:cNvSpPr/>
+          <p:nvPr/>
+        </p:nvSpPr>
+        <p:spPr>
+          <a:xfrm>
+            <a:off x="0" y="0"/>
+            <a:ext cx="4063898" cy="45720"/>
+          </a:xfrm>
+          <a:prstGeom prst="rect">
+            <a:avLst/>
+          </a:prstGeom>
+          <a:solidFill>
+            <a:srgbClr val="6AB0F3"/>
+          </a:solidFill>
+          <a:ln>
+            <a:noFill/>
+          </a:ln>
+        </p:spPr>
+        <p:style>
+          <a:lnRef idx="1">
+            <a:schemeClr val="accent1"/>
+          </a:lnRef>
+          <a:fillRef idx="3">
+            <a:schemeClr val="accent1"/>
+          </a:fillRef>
+          <a:effectRef idx="2">
+            <a:schemeClr val="accent1"/>
+          </a:effectRef>
+          <a:fontRef idx="minor">
+            <a:schemeClr val="lt1"/>
+          </a:fontRef>
+        </p:style>
+        <p:txBody>
+          <a:bodyPr rtlCol="0" anchor="ctr"/>
+          <a:lstStyle/>
+          <a:p>
+            <a:pPr algn="ctr"/>
+          </a:p>
+        </p:txBody>
+      </p:sp>
+      <p:sp>
+        <p:nvSpPr>
+          <p:cNvPr id="3" name="Rectangle 2"/>
+          <p:cNvSpPr/>
+          <p:nvPr/>
+        </p:nvSpPr>
+        <p:spPr>
+          <a:xfrm>
+            <a:off x="4063898" y="0"/>
+            <a:ext cx="4063898" cy="45720"/>
+          </a:xfrm>
+          <a:prstGeom prst="rect">
+            <a:avLst/>
+          </a:prstGeom>
+          <a:solidFill>
+            <a:srgbClr val="BE8CFF"/>
+          </a:solidFill>
+          <a:ln>
+            <a:noFill/>
+          </a:ln>
+        </p:spPr>
+        <p:style>
+          <a:lnRef idx="1">
+            <a:schemeClr val="accent1"/>
+          </a:lnRef>
+          <a:fillRef idx="3">
+            <a:schemeClr val="accent1"/>
+          </a:fillRef>
+          <a:effectRef idx="2">
+            <a:schemeClr val="accent1"/>
+          </a:effectRef>
+          <a:fontRef idx="minor">
+            <a:schemeClr val="lt1"/>
+          </a:fontRef>
+        </p:style>
+        <p:txBody>
+          <a:bodyPr rtlCol="0" anchor="ctr"/>
+          <a:lstStyle/>
+          <a:p>
+            <a:pPr algn="ctr"/>
+          </a:p>
+        </p:txBody>
+      </p:sp>
+      <p:sp>
+        <p:nvSpPr>
+          <p:cNvPr id="4" name="Rectangle 3"/>
+          <p:cNvSpPr/>
+          <p:nvPr/>
+        </p:nvSpPr>
+        <p:spPr>
+          <a:xfrm>
+            <a:off x="8127796" y="0"/>
+            <a:ext cx="4063898" cy="45720"/>
+          </a:xfrm>
+          <a:prstGeom prst="rect">
+            <a:avLst/>
+          </a:prstGeom>
+          <a:solidFill>
+            <a:srgbClr val="00E6FF"/>
+          </a:solidFill>
+          <a:ln>
+            <a:noFill/>
+          </a:ln>
+        </p:spPr>
+        <p:style>
+          <a:lnRef idx="1">
+            <a:schemeClr val="accent1"/>
+          </a:lnRef>
+          <a:fillRef idx="3">
+            <a:schemeClr val="accent1"/>
+          </a:fillRef>
+          <a:effectRef idx="2">
+            <a:schemeClr val="accent1"/>
+          </a:effectRef>
+          <a:fontRef idx="minor">
+            <a:schemeClr val="lt1"/>
+          </a:fontRef>
+        </p:style>
+        <p:txBody>
+          <a:bodyPr rtlCol="0" anchor="ctr"/>
+          <a:lstStyle/>
+          <a:p>
+            <a:pPr algn="ctr"/>
+          </a:p>
+        </p:txBody>
+      </p:sp>
+      <p:sp>
+        <p:nvSpPr>
+          <p:cNvPr id="5" name="Oval 4"/>
+          <p:cNvSpPr/>
+          <p:nvPr/>
+        </p:nvSpPr>
+        <p:spPr>
+          <a:xfrm>
+            <a:off x="4114800" y="914400"/>
+            <a:ext cx="3962095" cy="3962095"/>
+          </a:xfrm>
+          <a:prstGeom prst="ellipse">
+            <a:avLst/>
+          </a:prstGeom>
+          <a:solidFill>
+            <a:srgbClr val="12182D"/>
+          </a:solidFill>
+          <a:ln>
+            <a:noFill/>
+          </a:ln>
+        </p:spPr>
+        <p:style>
+          <a:lnRef idx="1">
+            <a:schemeClr val="accent1"/>
+          </a:lnRef>
+          <a:fillRef idx="3">
+            <a:schemeClr val="accent1"/>
+          </a:fillRef>
+          <a:effectRef idx="2">
+            <a:schemeClr val="accent1"/>
+          </a:effectRef>
+          <a:fontRef idx="minor">
+            <a:schemeClr val="lt1"/>
+          </a:fontRef>
+        </p:style>
+        <p:txBody>
+          <a:bodyPr rtlCol="0" anchor="ctr"/>
+          <a:lstStyle/>
+          <a:p>
+            <a:pPr algn="ctr"/>
+          </a:p>
+        </p:txBody>
+      </p:sp>
+      <p:sp>
+        <p:nvSpPr>
+          <p:cNvPr id="6" name="TextBox 5"/>
+          <p:cNvSpPr txBox="1"/>
+          <p:nvPr/>
+        </p:nvSpPr>
+        <p:spPr>
+          <a:xfrm>
+            <a:off x="914400" y="2011680"/>
+            <a:ext cx="10362895" cy="1371600"/>
+          </a:xfrm>
+          <a:prstGeom prst="rect">
+            <a:avLst/>
+          </a:prstGeom>
+          <a:noFill/>
+        </p:spPr>
+        <p:txBody>
+          <a:bodyPr wrap="none">
+            <a:spAutoFit/>
+          </a:bodyPr>
+          <a:lstStyle/>
+          <a:p>
+            <a:pPr algn="ctr">
+              <a:defRPr sz="7200" b="1">
+                <a:solidFill>
+                  <a:srgbClr val="F8F9FA"/>
+                </a:solidFill>
+                <a:latin typeface="Google Sans"/>
               </a:defRPr>
             </a:pPr>
             <a:r>
@@ -3127,61 +3314,72 @@
       </p:sp>
       <p:sp>
         <p:nvSpPr>
-          <p:cNvPr id="3" name="Subtitle 2"/>
-          <p:cNvSpPr>
-            <a:spLocks noGrp="1"/>
-          </p:cNvSpPr>
-          <p:nvPr>
-            <p:ph type="subTitle" idx="1"/>
-          </p:nvPr>
-        </p:nvSpPr>
-        <p:spPr/>
-        <p:txBody>
-          <a:bodyPr/>
-          <a:lstStyle/>
-          <a:p>
-            <a:pPr>
-              <a:defRPr sz="2000" b="0">
-                <a:solidFill>
-                  <a:srgbClr val="5F6368"/>
-                </a:solidFill>
-                <a:latin typeface="Arial"/>
+          <p:cNvPr id="7" name="TextBox 6"/>
+          <p:cNvSpPr txBox="1"/>
+          <p:nvPr/>
+        </p:nvSpPr>
+        <p:spPr>
+          <a:xfrm>
+            <a:off x="914400" y="3657600"/>
+            <a:ext cx="10362895" cy="914400"/>
+          </a:xfrm>
+          <a:prstGeom prst="rect">
+            <a:avLst/>
+          </a:prstGeom>
+          <a:noFill/>
+        </p:spPr>
+        <p:txBody>
+          <a:bodyPr wrap="none">
+            <a:spAutoFit/>
+          </a:bodyPr>
+          <a:lstStyle/>
+          <a:p>
+            <a:pPr algn="ctr">
+              <a:defRPr sz="2800">
+                <a:solidFill>
+                  <a:srgbClr val="6AB0F3"/>
+                </a:solidFill>
+                <a:latin typeface="Google Sans"/>
               </a:defRPr>
             </a:pPr>
             <a:r>
-              <a:t>Hyperlocalized Context Builder from Everyday Photos</a:t>
-            </a:r>
-          </a:p>
-          <a:p>
-            <a:pPr>
-              <a:defRPr sz="2000" b="0">
-                <a:solidFill>
-                  <a:srgbClr val="5F6368"/>
-                </a:solidFill>
-                <a:latin typeface="Arial"/>
-              </a:defRPr>
-            </a:pPr>
-            <a:r>
-              <a:t>Gemini AI Tokyo Hackathon 2026</a:t>
-            </a:r>
-          </a:p>
-          <a:p>
-            <a:pPr>
-              <a:defRPr sz="2000" b="0">
-                <a:solidFill>
-                  <a:srgbClr val="5F6368"/>
-                </a:solidFill>
-                <a:latin typeface="Arial"/>
-              </a:defRPr>
-            </a:pPr>
-          </a:p>
-          <a:p>
-            <a:pPr>
-              <a:defRPr sz="2000" b="0">
-                <a:solidFill>
-                  <a:srgbClr val="5F6368"/>
-                </a:solidFill>
-                <a:latin typeface="Arial"/>
+              <a:t>Hyperlocalized Context Builder</a:t>
+            </a:r>
+            <a:br/>
+            <a:r>
+              <a:t>Powered by Gemini Advanced</a:t>
+            </a:r>
+          </a:p>
+        </p:txBody>
+      </p:sp>
+      <p:sp>
+        <p:nvSpPr>
+          <p:cNvPr id="8" name="TextBox 7"/>
+          <p:cNvSpPr txBox="1"/>
+          <p:nvPr/>
+        </p:nvSpPr>
+        <p:spPr>
+          <a:xfrm>
+            <a:off x="914400" y="5486400"/>
+            <a:ext cx="10362895" cy="914400"/>
+          </a:xfrm>
+          <a:prstGeom prst="rect">
+            <a:avLst/>
+          </a:prstGeom>
+          <a:noFill/>
+        </p:spPr>
+        <p:txBody>
+          <a:bodyPr wrap="none">
+            <a:spAutoFit/>
+          </a:bodyPr>
+          <a:lstStyle/>
+          <a:p>
+            <a:pPr algn="ctr">
+              <a:defRPr sz="1800">
+                <a:solidFill>
+                  <a:srgbClr val="A8B0B9"/>
+                </a:solidFill>
+                <a:latin typeface="Google Sans"/>
               </a:defRPr>
             </a:pPr>
             <a:r>
@@ -3201,6 +3399,14 @@
 <file path=ppt/slides/slide2.xml><?xml version="1.0" encoding="utf-8"?>
 <p:sld xmlns:a="http://schemas.openxmlformats.org/drawingml/2006/main" xmlns:p="http://schemas.openxmlformats.org/presentationml/2006/main" xmlns:r="http://schemas.openxmlformats.org/officeDocument/2006/relationships">
   <p:cSld>
+    <p:bg>
+      <p:bgPr>
+        <a:solidFill>
+          <a:srgbClr val="0B0F19"/>
+        </a:solidFill>
+        <a:effectLst/>
+      </p:bgPr>
+    </p:bg>
     <p:spTree>
       <p:nvGrpSpPr>
         <p:cNvPr id="1" name=""/>
@@ -3210,25 +3416,161 @@
       <p:grpSpPr/>
       <p:sp>
         <p:nvSpPr>
-          <p:cNvPr id="2" name="Title 1"/>
-          <p:cNvSpPr>
-            <a:spLocks noGrp="1"/>
-          </p:cNvSpPr>
-          <p:nvPr>
-            <p:ph type="title"/>
-          </p:nvPr>
-        </p:nvSpPr>
-        <p:spPr/>
-        <p:txBody>
-          <a:bodyPr/>
-          <a:lstStyle/>
-          <a:p>
-            <a:pPr>
-              <a:defRPr sz="3600" b="1">
-                <a:solidFill>
-                  <a:srgbClr val="EA4335"/>
-                </a:solidFill>
-                <a:latin typeface="Arial"/>
+          <p:cNvPr id="2" name="Rectangle 1"/>
+          <p:cNvSpPr/>
+          <p:nvPr/>
+        </p:nvSpPr>
+        <p:spPr>
+          <a:xfrm>
+            <a:off x="0" y="0"/>
+            <a:ext cx="4063898" cy="45720"/>
+          </a:xfrm>
+          <a:prstGeom prst="rect">
+            <a:avLst/>
+          </a:prstGeom>
+          <a:solidFill>
+            <a:srgbClr val="6AB0F3"/>
+          </a:solidFill>
+          <a:ln>
+            <a:noFill/>
+          </a:ln>
+        </p:spPr>
+        <p:style>
+          <a:lnRef idx="1">
+            <a:schemeClr val="accent1"/>
+          </a:lnRef>
+          <a:fillRef idx="3">
+            <a:schemeClr val="accent1"/>
+          </a:fillRef>
+          <a:effectRef idx="2">
+            <a:schemeClr val="accent1"/>
+          </a:effectRef>
+          <a:fontRef idx="minor">
+            <a:schemeClr val="lt1"/>
+          </a:fontRef>
+        </p:style>
+        <p:txBody>
+          <a:bodyPr rtlCol="0" anchor="ctr"/>
+          <a:lstStyle/>
+          <a:p>
+            <a:pPr algn="ctr"/>
+          </a:p>
+        </p:txBody>
+      </p:sp>
+      <p:sp>
+        <p:nvSpPr>
+          <p:cNvPr id="3" name="Rectangle 2"/>
+          <p:cNvSpPr/>
+          <p:nvPr/>
+        </p:nvSpPr>
+        <p:spPr>
+          <a:xfrm>
+            <a:off x="4063898" y="0"/>
+            <a:ext cx="4063898" cy="45720"/>
+          </a:xfrm>
+          <a:prstGeom prst="rect">
+            <a:avLst/>
+          </a:prstGeom>
+          <a:solidFill>
+            <a:srgbClr val="BE8CFF"/>
+          </a:solidFill>
+          <a:ln>
+            <a:noFill/>
+          </a:ln>
+        </p:spPr>
+        <p:style>
+          <a:lnRef idx="1">
+            <a:schemeClr val="accent1"/>
+          </a:lnRef>
+          <a:fillRef idx="3">
+            <a:schemeClr val="accent1"/>
+          </a:fillRef>
+          <a:effectRef idx="2">
+            <a:schemeClr val="accent1"/>
+          </a:effectRef>
+          <a:fontRef idx="minor">
+            <a:schemeClr val="lt1"/>
+          </a:fontRef>
+        </p:style>
+        <p:txBody>
+          <a:bodyPr rtlCol="0" anchor="ctr"/>
+          <a:lstStyle/>
+          <a:p>
+            <a:pPr algn="ctr"/>
+          </a:p>
+        </p:txBody>
+      </p:sp>
+      <p:sp>
+        <p:nvSpPr>
+          <p:cNvPr id="4" name="Rectangle 3"/>
+          <p:cNvSpPr/>
+          <p:nvPr/>
+        </p:nvSpPr>
+        <p:spPr>
+          <a:xfrm>
+            <a:off x="8127796" y="0"/>
+            <a:ext cx="4063898" cy="45720"/>
+          </a:xfrm>
+          <a:prstGeom prst="rect">
+            <a:avLst/>
+          </a:prstGeom>
+          <a:solidFill>
+            <a:srgbClr val="00E6FF"/>
+          </a:solidFill>
+          <a:ln>
+            <a:noFill/>
+          </a:ln>
+        </p:spPr>
+        <p:style>
+          <a:lnRef idx="1">
+            <a:schemeClr val="accent1"/>
+          </a:lnRef>
+          <a:fillRef idx="3">
+            <a:schemeClr val="accent1"/>
+          </a:fillRef>
+          <a:effectRef idx="2">
+            <a:schemeClr val="accent1"/>
+          </a:effectRef>
+          <a:fontRef idx="minor">
+            <a:schemeClr val="lt1"/>
+          </a:fontRef>
+        </p:style>
+        <p:txBody>
+          <a:bodyPr rtlCol="0" anchor="ctr"/>
+          <a:lstStyle/>
+          <a:p>
+            <a:pPr algn="ctr"/>
+          </a:p>
+        </p:txBody>
+      </p:sp>
+      <p:sp>
+        <p:nvSpPr>
+          <p:cNvPr id="5" name="TextBox 4"/>
+          <p:cNvSpPr txBox="1"/>
+          <p:nvPr/>
+        </p:nvSpPr>
+        <p:spPr>
+          <a:xfrm>
+            <a:off x="914400" y="457200"/>
+            <a:ext cx="10362895" cy="914400"/>
+          </a:xfrm>
+          <a:prstGeom prst="rect">
+            <a:avLst/>
+          </a:prstGeom>
+          <a:noFill/>
+        </p:spPr>
+        <p:txBody>
+          <a:bodyPr wrap="none">
+            <a:spAutoFit/>
+          </a:bodyPr>
+          <a:lstStyle/>
+          <a:p>
+            <a:pPr algn="l">
+              <a:defRPr sz="4000" b="1">
+                <a:solidFill>
+                  <a:srgbClr val="F8F9FA"/>
+                </a:solidFill>
+                <a:latin typeface="Google Sans"/>
               </a:defRPr>
             </a:pPr>
             <a:r>
@@ -3239,25 +3581,94 @@
       </p:sp>
       <p:sp>
         <p:nvSpPr>
-          <p:cNvPr id="3" name="Content Placeholder 2"/>
-          <p:cNvSpPr>
-            <a:spLocks noGrp="1"/>
-          </p:cNvSpPr>
-          <p:nvPr>
-            <p:ph idx="1"/>
-          </p:nvPr>
-        </p:nvSpPr>
-        <p:spPr/>
-        <p:txBody>
-          <a:bodyPr/>
-          <a:lstStyle/>
-          <a:p>
-            <a:pPr>
-              <a:defRPr sz="2000" b="1">
-                <a:solidFill>
-                  <a:srgbClr val="202124"/>
-                </a:solidFill>
-                <a:latin typeface="Arial"/>
+          <p:cNvPr id="6" name="Oval 5"/>
+          <p:cNvSpPr/>
+          <p:nvPr/>
+        </p:nvSpPr>
+        <p:spPr>
+          <a:xfrm>
+            <a:off x="548640" y="777240"/>
+            <a:ext cx="137160" cy="137160"/>
+          </a:xfrm>
+          <a:prstGeom prst="ellipse">
+            <a:avLst/>
+          </a:prstGeom>
+          <a:solidFill>
+            <a:srgbClr val="FF8AB3"/>
+          </a:solidFill>
+          <a:ln>
+            <a:noFill/>
+          </a:ln>
+        </p:spPr>
+        <p:style>
+          <a:lnRef idx="1">
+            <a:schemeClr val="accent1"/>
+          </a:lnRef>
+          <a:fillRef idx="3">
+            <a:schemeClr val="accent1"/>
+          </a:fillRef>
+          <a:effectRef idx="2">
+            <a:schemeClr val="accent1"/>
+          </a:effectRef>
+          <a:fontRef idx="minor">
+            <a:schemeClr val="lt1"/>
+          </a:fontRef>
+        </p:style>
+        <p:txBody>
+          <a:bodyPr rtlCol="0" anchor="ctr"/>
+          <a:lstStyle/>
+          <a:p>
+            <a:pPr algn="ctr"/>
+          </a:p>
+        </p:txBody>
+      </p:sp>
+      <p:sp>
+        <p:nvSpPr>
+          <p:cNvPr id="7" name="Rounded Rectangle 6"/>
+          <p:cNvSpPr/>
+          <p:nvPr/>
+        </p:nvSpPr>
+        <p:spPr>
+          <a:xfrm>
+            <a:off x="914400" y="1645920"/>
+            <a:ext cx="10362895" cy="4572000"/>
+          </a:xfrm>
+          <a:prstGeom prst="roundRect">
+            <a:avLst/>
+          </a:prstGeom>
+          <a:solidFill>
+            <a:srgbClr val="141A28"/>
+          </a:solidFill>
+          <a:ln w="12700">
+            <a:solidFill>
+              <a:srgbClr val="283041"/>
+            </a:solidFill>
+          </a:ln>
+        </p:spPr>
+        <p:style>
+          <a:lnRef idx="1">
+            <a:schemeClr val="accent1"/>
+          </a:lnRef>
+          <a:fillRef idx="3">
+            <a:schemeClr val="accent1"/>
+          </a:fillRef>
+          <a:effectRef idx="2">
+            <a:schemeClr val="accent1"/>
+          </a:effectRef>
+          <a:fontRef idx="minor">
+            <a:schemeClr val="lt1"/>
+          </a:fontRef>
+        </p:style>
+        <p:txBody>
+          <a:bodyPr rtlCol="0" anchor="ctr" wrap="square" lIns="457200" rIns="457200" tIns="457200"/>
+          <a:lstStyle/>
+          <a:p>
+            <a:pPr algn="ctr">
+              <a:defRPr sz="2800" b="1">
+                <a:solidFill>
+                  <a:srgbClr val="FF8AB3"/>
+                </a:solidFill>
+                <a:latin typeface="Google Sans"/>
               </a:defRPr>
             </a:pPr>
             <a:r>
@@ -3266,11 +3677,14 @@
           </a:p>
           <a:p>
             <a:pPr lvl="1">
-              <a:defRPr sz="1800" b="0">
-                <a:solidFill>
-                  <a:srgbClr val="202124"/>
-                </a:solidFill>
-                <a:latin typeface="Arial"/>
+              <a:spcBef>
+                <a:spcPts val="1200"/>
+              </a:spcBef>
+              <a:defRPr sz="2200">
+                <a:solidFill>
+                  <a:srgbClr val="A8B0B9"/>
+                </a:solidFill>
+                <a:latin typeface="Google Sans"/>
               </a:defRPr>
             </a:pPr>
             <a:r>
@@ -3279,11 +3693,14 @@
           </a:p>
           <a:p>
             <a:pPr lvl="1">
-              <a:defRPr sz="1800" b="0">
-                <a:solidFill>
-                  <a:srgbClr val="202124"/>
-                </a:solidFill>
-                <a:latin typeface="Arial"/>
+              <a:spcBef>
+                <a:spcPts val="1200"/>
+              </a:spcBef>
+              <a:defRPr sz="2200">
+                <a:solidFill>
+                  <a:srgbClr val="A8B0B9"/>
+                </a:solidFill>
+                <a:latin typeface="Google Sans"/>
               </a:defRPr>
             </a:pPr>
             <a:r>
@@ -3292,11 +3709,14 @@
           </a:p>
           <a:p>
             <a:pPr lvl="1">
-              <a:defRPr sz="1800" b="0">
-                <a:solidFill>
-                  <a:srgbClr val="202124"/>
-                </a:solidFill>
-                <a:latin typeface="Arial"/>
+              <a:spcBef>
+                <a:spcPts val="1200"/>
+              </a:spcBef>
+              <a:defRPr sz="2200">
+                <a:solidFill>
+                  <a:srgbClr val="A8B0B9"/>
+                </a:solidFill>
+                <a:latin typeface="Google Sans"/>
               </a:defRPr>
             </a:pPr>
             <a:r>
@@ -3316,6 +3736,14 @@
 <file path=ppt/slides/slide3.xml><?xml version="1.0" encoding="utf-8"?>
 <p:sld xmlns:a="http://schemas.openxmlformats.org/drawingml/2006/main" xmlns:p="http://schemas.openxmlformats.org/presentationml/2006/main" xmlns:r="http://schemas.openxmlformats.org/officeDocument/2006/relationships">
   <p:cSld>
+    <p:bg>
+      <p:bgPr>
+        <a:solidFill>
+          <a:srgbClr val="0B0F19"/>
+        </a:solidFill>
+        <a:effectLst/>
+      </p:bgPr>
+    </p:bg>
     <p:spTree>
       <p:nvGrpSpPr>
         <p:cNvPr id="1" name=""/>
@@ -3325,25 +3753,161 @@
       <p:grpSpPr/>
       <p:sp>
         <p:nvSpPr>
-          <p:cNvPr id="2" name="Title 1"/>
-          <p:cNvSpPr>
-            <a:spLocks noGrp="1"/>
-          </p:cNvSpPr>
-          <p:nvPr>
-            <p:ph type="title"/>
-          </p:nvPr>
-        </p:nvSpPr>
-        <p:spPr/>
-        <p:txBody>
-          <a:bodyPr/>
-          <a:lstStyle/>
-          <a:p>
-            <a:pPr>
-              <a:defRPr sz="3600" b="1">
-                <a:solidFill>
-                  <a:srgbClr val="34A853"/>
-                </a:solidFill>
-                <a:latin typeface="Arial"/>
+          <p:cNvPr id="2" name="Rectangle 1"/>
+          <p:cNvSpPr/>
+          <p:nvPr/>
+        </p:nvSpPr>
+        <p:spPr>
+          <a:xfrm>
+            <a:off x="0" y="0"/>
+            <a:ext cx="4063898" cy="45720"/>
+          </a:xfrm>
+          <a:prstGeom prst="rect">
+            <a:avLst/>
+          </a:prstGeom>
+          <a:solidFill>
+            <a:srgbClr val="6AB0F3"/>
+          </a:solidFill>
+          <a:ln>
+            <a:noFill/>
+          </a:ln>
+        </p:spPr>
+        <p:style>
+          <a:lnRef idx="1">
+            <a:schemeClr val="accent1"/>
+          </a:lnRef>
+          <a:fillRef idx="3">
+            <a:schemeClr val="accent1"/>
+          </a:fillRef>
+          <a:effectRef idx="2">
+            <a:schemeClr val="accent1"/>
+          </a:effectRef>
+          <a:fontRef idx="minor">
+            <a:schemeClr val="lt1"/>
+          </a:fontRef>
+        </p:style>
+        <p:txBody>
+          <a:bodyPr rtlCol="0" anchor="ctr"/>
+          <a:lstStyle/>
+          <a:p>
+            <a:pPr algn="ctr"/>
+          </a:p>
+        </p:txBody>
+      </p:sp>
+      <p:sp>
+        <p:nvSpPr>
+          <p:cNvPr id="3" name="Rectangle 2"/>
+          <p:cNvSpPr/>
+          <p:nvPr/>
+        </p:nvSpPr>
+        <p:spPr>
+          <a:xfrm>
+            <a:off x="4063898" y="0"/>
+            <a:ext cx="4063898" cy="45720"/>
+          </a:xfrm>
+          <a:prstGeom prst="rect">
+            <a:avLst/>
+          </a:prstGeom>
+          <a:solidFill>
+            <a:srgbClr val="BE8CFF"/>
+          </a:solidFill>
+          <a:ln>
+            <a:noFill/>
+          </a:ln>
+        </p:spPr>
+        <p:style>
+          <a:lnRef idx="1">
+            <a:schemeClr val="accent1"/>
+          </a:lnRef>
+          <a:fillRef idx="3">
+            <a:schemeClr val="accent1"/>
+          </a:fillRef>
+          <a:effectRef idx="2">
+            <a:schemeClr val="accent1"/>
+          </a:effectRef>
+          <a:fontRef idx="minor">
+            <a:schemeClr val="lt1"/>
+          </a:fontRef>
+        </p:style>
+        <p:txBody>
+          <a:bodyPr rtlCol="0" anchor="ctr"/>
+          <a:lstStyle/>
+          <a:p>
+            <a:pPr algn="ctr"/>
+          </a:p>
+        </p:txBody>
+      </p:sp>
+      <p:sp>
+        <p:nvSpPr>
+          <p:cNvPr id="4" name="Rectangle 3"/>
+          <p:cNvSpPr/>
+          <p:nvPr/>
+        </p:nvSpPr>
+        <p:spPr>
+          <a:xfrm>
+            <a:off x="8127796" y="0"/>
+            <a:ext cx="4063898" cy="45720"/>
+          </a:xfrm>
+          <a:prstGeom prst="rect">
+            <a:avLst/>
+          </a:prstGeom>
+          <a:solidFill>
+            <a:srgbClr val="00E6FF"/>
+          </a:solidFill>
+          <a:ln>
+            <a:noFill/>
+          </a:ln>
+        </p:spPr>
+        <p:style>
+          <a:lnRef idx="1">
+            <a:schemeClr val="accent1"/>
+          </a:lnRef>
+          <a:fillRef idx="3">
+            <a:schemeClr val="accent1"/>
+          </a:fillRef>
+          <a:effectRef idx="2">
+            <a:schemeClr val="accent1"/>
+          </a:effectRef>
+          <a:fontRef idx="minor">
+            <a:schemeClr val="lt1"/>
+          </a:fontRef>
+        </p:style>
+        <p:txBody>
+          <a:bodyPr rtlCol="0" anchor="ctr"/>
+          <a:lstStyle/>
+          <a:p>
+            <a:pPr algn="ctr"/>
+          </a:p>
+        </p:txBody>
+      </p:sp>
+      <p:sp>
+        <p:nvSpPr>
+          <p:cNvPr id="5" name="TextBox 4"/>
+          <p:cNvSpPr txBox="1"/>
+          <p:nvPr/>
+        </p:nvSpPr>
+        <p:spPr>
+          <a:xfrm>
+            <a:off x="914400" y="457200"/>
+            <a:ext cx="10362895" cy="914400"/>
+          </a:xfrm>
+          <a:prstGeom prst="rect">
+            <a:avLst/>
+          </a:prstGeom>
+          <a:noFill/>
+        </p:spPr>
+        <p:txBody>
+          <a:bodyPr wrap="none">
+            <a:spAutoFit/>
+          </a:bodyPr>
+          <a:lstStyle/>
+          <a:p>
+            <a:pPr algn="l">
+              <a:defRPr sz="4000" b="1">
+                <a:solidFill>
+                  <a:srgbClr val="F8F9FA"/>
+                </a:solidFill>
+                <a:latin typeface="Google Sans"/>
               </a:defRPr>
             </a:pPr>
             <a:r>
@@ -3354,25 +3918,94 @@
       </p:sp>
       <p:sp>
         <p:nvSpPr>
-          <p:cNvPr id="3" name="Content Placeholder 2"/>
-          <p:cNvSpPr>
-            <a:spLocks noGrp="1"/>
-          </p:cNvSpPr>
-          <p:nvPr>
-            <p:ph idx="1"/>
-          </p:nvPr>
-        </p:nvSpPr>
-        <p:spPr/>
-        <p:txBody>
-          <a:bodyPr/>
-          <a:lstStyle/>
-          <a:p>
-            <a:pPr>
-              <a:defRPr sz="2000" b="1">
-                <a:solidFill>
-                  <a:srgbClr val="202124"/>
-                </a:solidFill>
-                <a:latin typeface="Arial"/>
+          <p:cNvPr id="6" name="Oval 5"/>
+          <p:cNvSpPr/>
+          <p:nvPr/>
+        </p:nvSpPr>
+        <p:spPr>
+          <a:xfrm>
+            <a:off x="548640" y="777240"/>
+            <a:ext cx="137160" cy="137160"/>
+          </a:xfrm>
+          <a:prstGeom prst="ellipse">
+            <a:avLst/>
+          </a:prstGeom>
+          <a:solidFill>
+            <a:srgbClr val="00E6FF"/>
+          </a:solidFill>
+          <a:ln>
+            <a:noFill/>
+          </a:ln>
+        </p:spPr>
+        <p:style>
+          <a:lnRef idx="1">
+            <a:schemeClr val="accent1"/>
+          </a:lnRef>
+          <a:fillRef idx="3">
+            <a:schemeClr val="accent1"/>
+          </a:fillRef>
+          <a:effectRef idx="2">
+            <a:schemeClr val="accent1"/>
+          </a:effectRef>
+          <a:fontRef idx="minor">
+            <a:schemeClr val="lt1"/>
+          </a:fontRef>
+        </p:style>
+        <p:txBody>
+          <a:bodyPr rtlCol="0" anchor="ctr"/>
+          <a:lstStyle/>
+          <a:p>
+            <a:pPr algn="ctr"/>
+          </a:p>
+        </p:txBody>
+      </p:sp>
+      <p:sp>
+        <p:nvSpPr>
+          <p:cNvPr id="7" name="Rounded Rectangle 6"/>
+          <p:cNvSpPr/>
+          <p:nvPr/>
+        </p:nvSpPr>
+        <p:spPr>
+          <a:xfrm>
+            <a:off x="914400" y="1645920"/>
+            <a:ext cx="10362895" cy="4572000"/>
+          </a:xfrm>
+          <a:prstGeom prst="roundRect">
+            <a:avLst/>
+          </a:prstGeom>
+          <a:solidFill>
+            <a:srgbClr val="141A28"/>
+          </a:solidFill>
+          <a:ln w="12700">
+            <a:solidFill>
+              <a:srgbClr val="283041"/>
+            </a:solidFill>
+          </a:ln>
+        </p:spPr>
+        <p:style>
+          <a:lnRef idx="1">
+            <a:schemeClr val="accent1"/>
+          </a:lnRef>
+          <a:fillRef idx="3">
+            <a:schemeClr val="accent1"/>
+          </a:fillRef>
+          <a:effectRef idx="2">
+            <a:schemeClr val="accent1"/>
+          </a:effectRef>
+          <a:fontRef idx="minor">
+            <a:schemeClr val="lt1"/>
+          </a:fontRef>
+        </p:style>
+        <p:txBody>
+          <a:bodyPr rtlCol="0" anchor="ctr" wrap="square" lIns="457200" rIns="457200" tIns="457200"/>
+          <a:lstStyle/>
+          <a:p>
+            <a:pPr algn="ctr">
+              <a:defRPr sz="2800" b="1">
+                <a:solidFill>
+                  <a:srgbClr val="00E6FF"/>
+                </a:solidFill>
+                <a:latin typeface="Google Sans"/>
               </a:defRPr>
             </a:pPr>
             <a:r>
@@ -3381,11 +4014,14 @@
           </a:p>
           <a:p>
             <a:pPr lvl="1">
-              <a:defRPr sz="1800" b="0">
-                <a:solidFill>
-                  <a:srgbClr val="202124"/>
-                </a:solidFill>
-                <a:latin typeface="Arial"/>
+              <a:spcBef>
+                <a:spcPts val="1200"/>
+              </a:spcBef>
+              <a:defRPr sz="2200">
+                <a:solidFill>
+                  <a:srgbClr val="A8B0B9"/>
+                </a:solidFill>
+                <a:latin typeface="Google Sans"/>
               </a:defRPr>
             </a:pPr>
             <a:r>
@@ -3394,11 +4030,14 @@
           </a:p>
           <a:p>
             <a:pPr lvl="1">
-              <a:defRPr sz="1800" b="0">
-                <a:solidFill>
-                  <a:srgbClr val="202124"/>
-                </a:solidFill>
-                <a:latin typeface="Arial"/>
+              <a:spcBef>
+                <a:spcPts val="1200"/>
+              </a:spcBef>
+              <a:defRPr sz="2200">
+                <a:solidFill>
+                  <a:srgbClr val="A8B0B9"/>
+                </a:solidFill>
+                <a:latin typeface="Google Sans"/>
               </a:defRPr>
             </a:pPr>
             <a:r>
@@ -3407,11 +4046,14 @@
           </a:p>
           <a:p>
             <a:pPr lvl="1">
-              <a:defRPr sz="1800" b="0">
-                <a:solidFill>
-                  <a:srgbClr val="202124"/>
-                </a:solidFill>
-                <a:latin typeface="Arial"/>
+              <a:spcBef>
+                <a:spcPts val="1200"/>
+              </a:spcBef>
+              <a:defRPr sz="2200">
+                <a:solidFill>
+                  <a:srgbClr val="A8B0B9"/>
+                </a:solidFill>
+                <a:latin typeface="Google Sans"/>
               </a:defRPr>
             </a:pPr>
             <a:r>
@@ -3431,6 +4073,14 @@
 <file path=ppt/slides/slide4.xml><?xml version="1.0" encoding="utf-8"?>
 <p:sld xmlns:a="http://schemas.openxmlformats.org/drawingml/2006/main" xmlns:p="http://schemas.openxmlformats.org/presentationml/2006/main" xmlns:r="http://schemas.openxmlformats.org/officeDocument/2006/relationships">
   <p:cSld>
+    <p:bg>
+      <p:bgPr>
+        <a:solidFill>
+          <a:srgbClr val="0B0F19"/>
+        </a:solidFill>
+        <a:effectLst/>
+      </p:bgPr>
+    </p:bg>
     <p:spTree>
       <p:nvGrpSpPr>
         <p:cNvPr id="1" name=""/>
@@ -3440,123 +4090,311 @@
       <p:grpSpPr/>
       <p:sp>
         <p:nvSpPr>
-          <p:cNvPr id="2" name="Title 1"/>
-          <p:cNvSpPr>
-            <a:spLocks noGrp="1"/>
-          </p:cNvSpPr>
-          <p:nvPr>
-            <p:ph type="title"/>
-          </p:nvPr>
-        </p:nvSpPr>
-        <p:spPr/>
-        <p:txBody>
-          <a:bodyPr/>
-          <a:lstStyle/>
-          <a:p>
-            <a:pPr>
-              <a:defRPr sz="3600" b="1">
-                <a:solidFill>
-                  <a:srgbClr val="FBBC05"/>
-                </a:solidFill>
-                <a:latin typeface="Arial"/>
+          <p:cNvPr id="2" name="Rectangle 1"/>
+          <p:cNvSpPr/>
+          <p:nvPr/>
+        </p:nvSpPr>
+        <p:spPr>
+          <a:xfrm>
+            <a:off x="0" y="0"/>
+            <a:ext cx="4063898" cy="45720"/>
+          </a:xfrm>
+          <a:prstGeom prst="rect">
+            <a:avLst/>
+          </a:prstGeom>
+          <a:solidFill>
+            <a:srgbClr val="6AB0F3"/>
+          </a:solidFill>
+          <a:ln>
+            <a:noFill/>
+          </a:ln>
+        </p:spPr>
+        <p:style>
+          <a:lnRef idx="1">
+            <a:schemeClr val="accent1"/>
+          </a:lnRef>
+          <a:fillRef idx="3">
+            <a:schemeClr val="accent1"/>
+          </a:fillRef>
+          <a:effectRef idx="2">
+            <a:schemeClr val="accent1"/>
+          </a:effectRef>
+          <a:fontRef idx="minor">
+            <a:schemeClr val="lt1"/>
+          </a:fontRef>
+        </p:style>
+        <p:txBody>
+          <a:bodyPr rtlCol="0" anchor="ctr"/>
+          <a:lstStyle/>
+          <a:p>
+            <a:pPr algn="ctr"/>
+          </a:p>
+        </p:txBody>
+      </p:sp>
+      <p:sp>
+        <p:nvSpPr>
+          <p:cNvPr id="3" name="Rectangle 2"/>
+          <p:cNvSpPr/>
+          <p:nvPr/>
+        </p:nvSpPr>
+        <p:spPr>
+          <a:xfrm>
+            <a:off x="4063898" y="0"/>
+            <a:ext cx="4063898" cy="45720"/>
+          </a:xfrm>
+          <a:prstGeom prst="rect">
+            <a:avLst/>
+          </a:prstGeom>
+          <a:solidFill>
+            <a:srgbClr val="BE8CFF"/>
+          </a:solidFill>
+          <a:ln>
+            <a:noFill/>
+          </a:ln>
+        </p:spPr>
+        <p:style>
+          <a:lnRef idx="1">
+            <a:schemeClr val="accent1"/>
+          </a:lnRef>
+          <a:fillRef idx="3">
+            <a:schemeClr val="accent1"/>
+          </a:fillRef>
+          <a:effectRef idx="2">
+            <a:schemeClr val="accent1"/>
+          </a:effectRef>
+          <a:fontRef idx="minor">
+            <a:schemeClr val="lt1"/>
+          </a:fontRef>
+        </p:style>
+        <p:txBody>
+          <a:bodyPr rtlCol="0" anchor="ctr"/>
+          <a:lstStyle/>
+          <a:p>
+            <a:pPr algn="ctr"/>
+          </a:p>
+        </p:txBody>
+      </p:sp>
+      <p:sp>
+        <p:nvSpPr>
+          <p:cNvPr id="4" name="Rectangle 3"/>
+          <p:cNvSpPr/>
+          <p:nvPr/>
+        </p:nvSpPr>
+        <p:spPr>
+          <a:xfrm>
+            <a:off x="8127796" y="0"/>
+            <a:ext cx="4063898" cy="45720"/>
+          </a:xfrm>
+          <a:prstGeom prst="rect">
+            <a:avLst/>
+          </a:prstGeom>
+          <a:solidFill>
+            <a:srgbClr val="00E6FF"/>
+          </a:solidFill>
+          <a:ln>
+            <a:noFill/>
+          </a:ln>
+        </p:spPr>
+        <p:style>
+          <a:lnRef idx="1">
+            <a:schemeClr val="accent1"/>
+          </a:lnRef>
+          <a:fillRef idx="3">
+            <a:schemeClr val="accent1"/>
+          </a:fillRef>
+          <a:effectRef idx="2">
+            <a:schemeClr val="accent1"/>
+          </a:effectRef>
+          <a:fontRef idx="minor">
+            <a:schemeClr val="lt1"/>
+          </a:fontRef>
+        </p:style>
+        <p:txBody>
+          <a:bodyPr rtlCol="0" anchor="ctr"/>
+          <a:lstStyle/>
+          <a:p>
+            <a:pPr algn="ctr"/>
+          </a:p>
+        </p:txBody>
+      </p:sp>
+      <p:sp>
+        <p:nvSpPr>
+          <p:cNvPr id="5" name="TextBox 4"/>
+          <p:cNvSpPr txBox="1"/>
+          <p:nvPr/>
+        </p:nvSpPr>
+        <p:spPr>
+          <a:xfrm>
+            <a:off x="914400" y="457200"/>
+            <a:ext cx="10362895" cy="914400"/>
+          </a:xfrm>
+          <a:prstGeom prst="rect">
+            <a:avLst/>
+          </a:prstGeom>
+          <a:noFill/>
+        </p:spPr>
+        <p:txBody>
+          <a:bodyPr wrap="none">
+            <a:spAutoFit/>
+          </a:bodyPr>
+          <a:lstStyle/>
+          <a:p>
+            <a:pPr algn="l">
+              <a:defRPr sz="4000" b="1">
+                <a:solidFill>
+                  <a:srgbClr val="F8F9FA"/>
+                </a:solidFill>
+                <a:latin typeface="Google Sans"/>
               </a:defRPr>
             </a:pPr>
             <a:r>
-              <a:t>3. How It Works (The 3-Step Magic)</a:t>
-            </a:r>
-          </a:p>
-        </p:txBody>
-      </p:sp>
-      <p:sp>
-        <p:nvSpPr>
-          <p:cNvPr id="3" name="Content Placeholder 2"/>
-          <p:cNvSpPr>
-            <a:spLocks noGrp="1"/>
-          </p:cNvSpPr>
-          <p:nvPr>
-            <p:ph idx="1"/>
-          </p:nvPr>
-        </p:nvSpPr>
-        <p:spPr/>
-        <p:txBody>
-          <a:bodyPr/>
-          <a:lstStyle/>
-          <a:p>
-            <a:pPr>
-              <a:defRPr sz="2000" b="1">
-                <a:solidFill>
-                  <a:srgbClr val="202124"/>
-                </a:solidFill>
-                <a:latin typeface="Arial"/>
+              <a:t>3. How It Works</a:t>
+            </a:r>
+          </a:p>
+        </p:txBody>
+      </p:sp>
+      <p:sp>
+        <p:nvSpPr>
+          <p:cNvPr id="6" name="Oval 5"/>
+          <p:cNvSpPr/>
+          <p:nvPr/>
+        </p:nvSpPr>
+        <p:spPr>
+          <a:xfrm>
+            <a:off x="548640" y="777240"/>
+            <a:ext cx="137160" cy="137160"/>
+          </a:xfrm>
+          <a:prstGeom prst="ellipse">
+            <a:avLst/>
+          </a:prstGeom>
+          <a:solidFill>
+            <a:srgbClr val="6AB0F3"/>
+          </a:solidFill>
+          <a:ln>
+            <a:noFill/>
+          </a:ln>
+        </p:spPr>
+        <p:style>
+          <a:lnRef idx="1">
+            <a:schemeClr val="accent1"/>
+          </a:lnRef>
+          <a:fillRef idx="3">
+            <a:schemeClr val="accent1"/>
+          </a:fillRef>
+          <a:effectRef idx="2">
+            <a:schemeClr val="accent1"/>
+          </a:effectRef>
+          <a:fontRef idx="minor">
+            <a:schemeClr val="lt1"/>
+          </a:fontRef>
+        </p:style>
+        <p:txBody>
+          <a:bodyPr rtlCol="0" anchor="ctr"/>
+          <a:lstStyle/>
+          <a:p>
+            <a:pPr algn="ctr"/>
+          </a:p>
+        </p:txBody>
+      </p:sp>
+      <p:sp>
+        <p:nvSpPr>
+          <p:cNvPr id="7" name="Rounded Rectangle 6"/>
+          <p:cNvSpPr/>
+          <p:nvPr/>
+        </p:nvSpPr>
+        <p:spPr>
+          <a:xfrm>
+            <a:off x="914400" y="1645920"/>
+            <a:ext cx="10362895" cy="4572000"/>
+          </a:xfrm>
+          <a:prstGeom prst="roundRect">
+            <a:avLst/>
+          </a:prstGeom>
+          <a:solidFill>
+            <a:srgbClr val="141A28"/>
+          </a:solidFill>
+          <a:ln w="12700">
+            <a:solidFill>
+              <a:srgbClr val="283041"/>
+            </a:solidFill>
+          </a:ln>
+        </p:spPr>
+        <p:style>
+          <a:lnRef idx="1">
+            <a:schemeClr val="accent1"/>
+          </a:lnRef>
+          <a:fillRef idx="3">
+            <a:schemeClr val="accent1"/>
+          </a:fillRef>
+          <a:effectRef idx="2">
+            <a:schemeClr val="accent1"/>
+          </a:effectRef>
+          <a:fontRef idx="minor">
+            <a:schemeClr val="lt1"/>
+          </a:fontRef>
+        </p:style>
+        <p:txBody>
+          <a:bodyPr rtlCol="0" anchor="ctr" wrap="square" lIns="457200" rIns="457200" tIns="457200"/>
+          <a:lstStyle/>
+          <a:p>
+            <a:pPr algn="ctr">
+              <a:defRPr sz="2800" b="1">
+                <a:solidFill>
+                  <a:srgbClr val="6AB0F3"/>
+                </a:solidFill>
+                <a:latin typeface="Google Sans"/>
               </a:defRPr>
             </a:pPr>
             <a:r>
-              <a:t>1. Capture &amp; Parse</a:t>
+              <a:t>The 3-Step Magic</a:t>
             </a:r>
           </a:p>
           <a:p>
             <a:pPr lvl="1">
-              <a:defRPr sz="1800" b="0">
-                <a:solidFill>
-                  <a:srgbClr val="202124"/>
-                </a:solidFill>
-                <a:latin typeface="Arial"/>
+              <a:spcBef>
+                <a:spcPts val="1200"/>
+              </a:spcBef>
+              <a:defRPr sz="2200">
+                <a:solidFill>
+                  <a:srgbClr val="A8B0B9"/>
+                </a:solidFill>
+                <a:latin typeface="Google Sans"/>
               </a:defRPr>
             </a:pPr>
             <a:r>
-              <a:t>- User uploads a photo. Gemini Vision API instantly extracts unstructured text to precise JSON.</a:t>
-            </a:r>
-          </a:p>
-          <a:p>
-            <a:pPr>
-              <a:defRPr sz="2000" b="1">
-                <a:solidFill>
-                  <a:srgbClr val="202124"/>
-                </a:solidFill>
-                <a:latin typeface="Arial"/>
+              <a:t>- 1. Capture &amp; Parse: User uploads a photo. Gemini Vision API instantly extracts unstructured text to precise JSON.</a:t>
+            </a:r>
+          </a:p>
+          <a:p>
+            <a:pPr lvl="1">
+              <a:spcBef>
+                <a:spcPts val="1200"/>
+              </a:spcBef>
+              <a:defRPr sz="2200">
+                <a:solidFill>
+                  <a:srgbClr val="A8B0B9"/>
+                </a:solidFill>
+                <a:latin typeface="Google Sans"/>
               </a:defRPr>
             </a:pPr>
             <a:r>
-              <a:t>2. Agentic Enrichment</a:t>
+              <a:t>- 2. Agentic Enrichment: Autonomous agent queries the web to find exact geo-coordinates and ticketing links.</a:t>
             </a:r>
           </a:p>
           <a:p>
             <a:pPr lvl="1">
-              <a:defRPr sz="1800" b="0">
-                <a:solidFill>
-                  <a:srgbClr val="202124"/>
-                </a:solidFill>
-                <a:latin typeface="Arial"/>
+              <a:spcBef>
+                <a:spcPts val="1200"/>
+              </a:spcBef>
+              <a:defRPr sz="2200">
+                <a:solidFill>
+                  <a:srgbClr val="A8B0B9"/>
+                </a:solidFill>
+                <a:latin typeface="Google Sans"/>
               </a:defRPr>
             </a:pPr>
             <a:r>
-              <a:t>- Autonomous agent queries the web to find exact geo-coordinates and ticketing links.</a:t>
-            </a:r>
-          </a:p>
-          <a:p>
-            <a:pPr>
-              <a:defRPr sz="2000" b="1">
-                <a:solidFill>
-                  <a:srgbClr val="202124"/>
-                </a:solidFill>
-                <a:latin typeface="Arial"/>
-              </a:defRPr>
-            </a:pPr>
-            <a:r>
-              <a:t>3. Interactive Map &amp; Concierge</a:t>
-            </a:r>
-          </a:p>
-          <a:p>
-            <a:pPr lvl="1">
-              <a:defRPr sz="1800" b="0">
-                <a:solidFill>
-                  <a:srgbClr val="202124"/>
-                </a:solidFill>
-                <a:latin typeface="Arial"/>
-              </a:defRPr>
-            </a:pPr>
-            <a:r>
-              <a:t>- Data drops onto a live map. Users ask the Local Lens Chatbot for recommendations based purely on uploaded data.</a:t>
+              <a:t>- 3. Interactive Map: Data drops onto a live map. Users ask the Local Lens Chatbot for recommendations.</a:t>
             </a:r>
           </a:p>
         </p:txBody>
@@ -3572,6 +4410,14 @@
 <file path=ppt/slides/slide5.xml><?xml version="1.0" encoding="utf-8"?>
 <p:sld xmlns:a="http://schemas.openxmlformats.org/drawingml/2006/main" xmlns:p="http://schemas.openxmlformats.org/presentationml/2006/main" xmlns:r="http://schemas.openxmlformats.org/officeDocument/2006/relationships">
   <p:cSld>
+    <p:bg>
+      <p:bgPr>
+        <a:solidFill>
+          <a:srgbClr val="0B0F19"/>
+        </a:solidFill>
+        <a:effectLst/>
+      </p:bgPr>
+    </p:bg>
     <p:spTree>
       <p:nvGrpSpPr>
         <p:cNvPr id="1" name=""/>
@@ -3581,25 +4427,161 @@
       <p:grpSpPr/>
       <p:sp>
         <p:nvSpPr>
-          <p:cNvPr id="2" name="Title 1"/>
-          <p:cNvSpPr>
-            <a:spLocks noGrp="1"/>
-          </p:cNvSpPr>
-          <p:nvPr>
-            <p:ph type="title"/>
-          </p:nvPr>
-        </p:nvSpPr>
-        <p:spPr/>
-        <p:txBody>
-          <a:bodyPr/>
-          <a:lstStyle/>
-          <a:p>
-            <a:pPr>
-              <a:defRPr sz="3600" b="1">
-                <a:solidFill>
-                  <a:srgbClr val="4285F4"/>
-                </a:solidFill>
-                <a:latin typeface="Arial"/>
+          <p:cNvPr id="2" name="Rectangle 1"/>
+          <p:cNvSpPr/>
+          <p:nvPr/>
+        </p:nvSpPr>
+        <p:spPr>
+          <a:xfrm>
+            <a:off x="0" y="0"/>
+            <a:ext cx="4063898" cy="45720"/>
+          </a:xfrm>
+          <a:prstGeom prst="rect">
+            <a:avLst/>
+          </a:prstGeom>
+          <a:solidFill>
+            <a:srgbClr val="6AB0F3"/>
+          </a:solidFill>
+          <a:ln>
+            <a:noFill/>
+          </a:ln>
+        </p:spPr>
+        <p:style>
+          <a:lnRef idx="1">
+            <a:schemeClr val="accent1"/>
+          </a:lnRef>
+          <a:fillRef idx="3">
+            <a:schemeClr val="accent1"/>
+          </a:fillRef>
+          <a:effectRef idx="2">
+            <a:schemeClr val="accent1"/>
+          </a:effectRef>
+          <a:fontRef idx="minor">
+            <a:schemeClr val="lt1"/>
+          </a:fontRef>
+        </p:style>
+        <p:txBody>
+          <a:bodyPr rtlCol="0" anchor="ctr"/>
+          <a:lstStyle/>
+          <a:p>
+            <a:pPr algn="ctr"/>
+          </a:p>
+        </p:txBody>
+      </p:sp>
+      <p:sp>
+        <p:nvSpPr>
+          <p:cNvPr id="3" name="Rectangle 2"/>
+          <p:cNvSpPr/>
+          <p:nvPr/>
+        </p:nvSpPr>
+        <p:spPr>
+          <a:xfrm>
+            <a:off x="4063898" y="0"/>
+            <a:ext cx="4063898" cy="45720"/>
+          </a:xfrm>
+          <a:prstGeom prst="rect">
+            <a:avLst/>
+          </a:prstGeom>
+          <a:solidFill>
+            <a:srgbClr val="BE8CFF"/>
+          </a:solidFill>
+          <a:ln>
+            <a:noFill/>
+          </a:ln>
+        </p:spPr>
+        <p:style>
+          <a:lnRef idx="1">
+            <a:schemeClr val="accent1"/>
+          </a:lnRef>
+          <a:fillRef idx="3">
+            <a:schemeClr val="accent1"/>
+          </a:fillRef>
+          <a:effectRef idx="2">
+            <a:schemeClr val="accent1"/>
+          </a:effectRef>
+          <a:fontRef idx="minor">
+            <a:schemeClr val="lt1"/>
+          </a:fontRef>
+        </p:style>
+        <p:txBody>
+          <a:bodyPr rtlCol="0" anchor="ctr"/>
+          <a:lstStyle/>
+          <a:p>
+            <a:pPr algn="ctr"/>
+          </a:p>
+        </p:txBody>
+      </p:sp>
+      <p:sp>
+        <p:nvSpPr>
+          <p:cNvPr id="4" name="Rectangle 3"/>
+          <p:cNvSpPr/>
+          <p:nvPr/>
+        </p:nvSpPr>
+        <p:spPr>
+          <a:xfrm>
+            <a:off x="8127796" y="0"/>
+            <a:ext cx="4063898" cy="45720"/>
+          </a:xfrm>
+          <a:prstGeom prst="rect">
+            <a:avLst/>
+          </a:prstGeom>
+          <a:solidFill>
+            <a:srgbClr val="00E6FF"/>
+          </a:solidFill>
+          <a:ln>
+            <a:noFill/>
+          </a:ln>
+        </p:spPr>
+        <p:style>
+          <a:lnRef idx="1">
+            <a:schemeClr val="accent1"/>
+          </a:lnRef>
+          <a:fillRef idx="3">
+            <a:schemeClr val="accent1"/>
+          </a:fillRef>
+          <a:effectRef idx="2">
+            <a:schemeClr val="accent1"/>
+          </a:effectRef>
+          <a:fontRef idx="minor">
+            <a:schemeClr val="lt1"/>
+          </a:fontRef>
+        </p:style>
+        <p:txBody>
+          <a:bodyPr rtlCol="0" anchor="ctr"/>
+          <a:lstStyle/>
+          <a:p>
+            <a:pPr algn="ctr"/>
+          </a:p>
+        </p:txBody>
+      </p:sp>
+      <p:sp>
+        <p:nvSpPr>
+          <p:cNvPr id="5" name="TextBox 4"/>
+          <p:cNvSpPr txBox="1"/>
+          <p:nvPr/>
+        </p:nvSpPr>
+        <p:spPr>
+          <a:xfrm>
+            <a:off x="914400" y="457200"/>
+            <a:ext cx="10362895" cy="914400"/>
+          </a:xfrm>
+          <a:prstGeom prst="rect">
+            <a:avLst/>
+          </a:prstGeom>
+          <a:noFill/>
+        </p:spPr>
+        <p:txBody>
+          <a:bodyPr wrap="none">
+            <a:spAutoFit/>
+          </a:bodyPr>
+          <a:lstStyle/>
+          <a:p>
+            <a:pPr algn="l">
+              <a:defRPr sz="4000" b="1">
+                <a:solidFill>
+                  <a:srgbClr val="F8F9FA"/>
+                </a:solidFill>
+                <a:latin typeface="Google Sans"/>
               </a:defRPr>
             </a:pPr>
             <a:r>
@@ -3610,25 +4592,94 @@
       </p:sp>
       <p:sp>
         <p:nvSpPr>
-          <p:cNvPr id="3" name="Content Placeholder 2"/>
-          <p:cNvSpPr>
-            <a:spLocks noGrp="1"/>
-          </p:cNvSpPr>
-          <p:nvPr>
-            <p:ph idx="1"/>
-          </p:nvPr>
-        </p:nvSpPr>
-        <p:spPr/>
-        <p:txBody>
-          <a:bodyPr/>
-          <a:lstStyle/>
-          <a:p>
-            <a:pPr>
-              <a:defRPr sz="2000" b="1">
-                <a:solidFill>
-                  <a:srgbClr val="202124"/>
-                </a:solidFill>
-                <a:latin typeface="Arial"/>
+          <p:cNvPr id="6" name="Oval 5"/>
+          <p:cNvSpPr/>
+          <p:nvPr/>
+        </p:nvSpPr>
+        <p:spPr>
+          <a:xfrm>
+            <a:off x="548640" y="777240"/>
+            <a:ext cx="137160" cy="137160"/>
+          </a:xfrm>
+          <a:prstGeom prst="ellipse">
+            <a:avLst/>
+          </a:prstGeom>
+          <a:solidFill>
+            <a:srgbClr val="BE8CFF"/>
+          </a:solidFill>
+          <a:ln>
+            <a:noFill/>
+          </a:ln>
+        </p:spPr>
+        <p:style>
+          <a:lnRef idx="1">
+            <a:schemeClr val="accent1"/>
+          </a:lnRef>
+          <a:fillRef idx="3">
+            <a:schemeClr val="accent1"/>
+          </a:fillRef>
+          <a:effectRef idx="2">
+            <a:schemeClr val="accent1"/>
+          </a:effectRef>
+          <a:fontRef idx="minor">
+            <a:schemeClr val="lt1"/>
+          </a:fontRef>
+        </p:style>
+        <p:txBody>
+          <a:bodyPr rtlCol="0" anchor="ctr"/>
+          <a:lstStyle/>
+          <a:p>
+            <a:pPr algn="ctr"/>
+          </a:p>
+        </p:txBody>
+      </p:sp>
+      <p:sp>
+        <p:nvSpPr>
+          <p:cNvPr id="7" name="Rounded Rectangle 6"/>
+          <p:cNvSpPr/>
+          <p:nvPr/>
+        </p:nvSpPr>
+        <p:spPr>
+          <a:xfrm>
+            <a:off x="914400" y="1645920"/>
+            <a:ext cx="10362895" cy="4572000"/>
+          </a:xfrm>
+          <a:prstGeom prst="roundRect">
+            <a:avLst/>
+          </a:prstGeom>
+          <a:solidFill>
+            <a:srgbClr val="141A28"/>
+          </a:solidFill>
+          <a:ln w="12700">
+            <a:solidFill>
+              <a:srgbClr val="283041"/>
+            </a:solidFill>
+          </a:ln>
+        </p:spPr>
+        <p:style>
+          <a:lnRef idx="1">
+            <a:schemeClr val="accent1"/>
+          </a:lnRef>
+          <a:fillRef idx="3">
+            <a:schemeClr val="accent1"/>
+          </a:fillRef>
+          <a:effectRef idx="2">
+            <a:schemeClr val="accent1"/>
+          </a:effectRef>
+          <a:fontRef idx="minor">
+            <a:schemeClr val="lt1"/>
+          </a:fontRef>
+        </p:style>
+        <p:txBody>
+          <a:bodyPr rtlCol="0" anchor="ctr" wrap="square" lIns="457200" rIns="457200" tIns="457200"/>
+          <a:lstStyle/>
+          <a:p>
+            <a:pPr algn="ctr">
+              <a:defRPr sz="2800" b="1">
+                <a:solidFill>
+                  <a:srgbClr val="BE8CFF"/>
+                </a:solidFill>
+                <a:latin typeface="Google Sans"/>
               </a:defRPr>
             </a:pPr>
             <a:r>
@@ -3637,11 +4688,14 @@
           </a:p>
           <a:p>
             <a:pPr lvl="1">
-              <a:defRPr sz="1800" b="0">
-                <a:solidFill>
-                  <a:srgbClr val="202124"/>
-                </a:solidFill>
-                <a:latin typeface="Arial"/>
+              <a:spcBef>
+                <a:spcPts val="1200"/>
+              </a:spcBef>
+              <a:defRPr sz="2200">
+                <a:solidFill>
+                  <a:srgbClr val="A8B0B9"/>
+                </a:solidFill>
+                <a:latin typeface="Google Sans"/>
               </a:defRPr>
             </a:pPr>
             <a:r>
@@ -3650,11 +4704,14 @@
           </a:p>
           <a:p>
             <a:pPr lvl="1">
-              <a:defRPr sz="1800" b="0">
-                <a:solidFill>
-                  <a:srgbClr val="202124"/>
-                </a:solidFill>
-                <a:latin typeface="Arial"/>
+              <a:spcBef>
+                <a:spcPts val="1200"/>
+              </a:spcBef>
+              <a:defRPr sz="2200">
+                <a:solidFill>
+                  <a:srgbClr val="A8B0B9"/>
+                </a:solidFill>
+                <a:latin typeface="Google Sans"/>
               </a:defRPr>
             </a:pPr>
             <a:r>
@@ -3663,11 +4720,14 @@
           </a:p>
           <a:p>
             <a:pPr lvl="1">
-              <a:defRPr sz="1800" b="0">
-                <a:solidFill>
-                  <a:srgbClr val="202124"/>
-                </a:solidFill>
-                <a:latin typeface="Arial"/>
+              <a:spcBef>
+                <a:spcPts val="1200"/>
+              </a:spcBef>
+              <a:defRPr sz="2200">
+                <a:solidFill>
+                  <a:srgbClr val="A8B0B9"/>
+                </a:solidFill>
+                <a:latin typeface="Google Sans"/>
               </a:defRPr>
             </a:pPr>
             <a:r>
@@ -3676,11 +4736,14 @@
           </a:p>
           <a:p>
             <a:pPr lvl="1">
-              <a:defRPr sz="1800" b="0">
-                <a:solidFill>
-                  <a:srgbClr val="202124"/>
-                </a:solidFill>
-                <a:latin typeface="Arial"/>
+              <a:spcBef>
+                <a:spcPts val="1200"/>
+              </a:spcBef>
+              <a:defRPr sz="2200">
+                <a:solidFill>
+                  <a:srgbClr val="A8B0B9"/>
+                </a:solidFill>
+                <a:latin typeface="Google Sans"/>
               </a:defRPr>
             </a:pPr>
             <a:r>
@@ -3689,11 +4752,14 @@
           </a:p>
           <a:p>
             <a:pPr lvl="1">
-              <a:defRPr sz="1800" b="0">
-                <a:solidFill>
-                  <a:srgbClr val="202124"/>
-                </a:solidFill>
-                <a:latin typeface="Arial"/>
+              <a:spcBef>
+                <a:spcPts val="1200"/>
+              </a:spcBef>
+              <a:defRPr sz="2200">
+                <a:solidFill>
+                  <a:srgbClr val="A8B0B9"/>
+                </a:solidFill>
+                <a:latin typeface="Google Sans"/>
               </a:defRPr>
             </a:pPr>
             <a:r>
@@ -3713,6 +4779,14 @@
 <file path=ppt/slides/slide6.xml><?xml version="1.0" encoding="utf-8"?>
 <p:sld xmlns:a="http://schemas.openxmlformats.org/drawingml/2006/main" xmlns:p="http://schemas.openxmlformats.org/presentationml/2006/main" xmlns:r="http://schemas.openxmlformats.org/officeDocument/2006/relationships">
   <p:cSld>
+    <p:bg>
+      <p:bgPr>
+        <a:solidFill>
+          <a:srgbClr val="0B0F19"/>
+        </a:solidFill>
+        <a:effectLst/>
+      </p:bgPr>
+    </p:bg>
     <p:spTree>
       <p:nvGrpSpPr>
         <p:cNvPr id="1" name=""/>
@@ -3722,54 +4796,259 @@
       <p:grpSpPr/>
       <p:sp>
         <p:nvSpPr>
-          <p:cNvPr id="2" name="Title 1"/>
-          <p:cNvSpPr>
-            <a:spLocks noGrp="1"/>
-          </p:cNvSpPr>
-          <p:nvPr>
-            <p:ph type="title"/>
-          </p:nvPr>
-        </p:nvSpPr>
-        <p:spPr/>
-        <p:txBody>
-          <a:bodyPr/>
-          <a:lstStyle/>
-          <a:p>
-            <a:pPr>
-              <a:defRPr sz="3600" b="1">
-                <a:solidFill>
-                  <a:srgbClr val="4285F4"/>
-                </a:solidFill>
-                <a:latin typeface="Arial"/>
+          <p:cNvPr id="2" name="Rectangle 1"/>
+          <p:cNvSpPr/>
+          <p:nvPr/>
+        </p:nvSpPr>
+        <p:spPr>
+          <a:xfrm>
+            <a:off x="0" y="0"/>
+            <a:ext cx="4063898" cy="45720"/>
+          </a:xfrm>
+          <a:prstGeom prst="rect">
+            <a:avLst/>
+          </a:prstGeom>
+          <a:solidFill>
+            <a:srgbClr val="6AB0F3"/>
+          </a:solidFill>
+          <a:ln>
+            <a:noFill/>
+          </a:ln>
+        </p:spPr>
+        <p:style>
+          <a:lnRef idx="1">
+            <a:schemeClr val="accent1"/>
+          </a:lnRef>
+          <a:fillRef idx="3">
+            <a:schemeClr val="accent1"/>
+          </a:fillRef>
+          <a:effectRef idx="2">
+            <a:schemeClr val="accent1"/>
+          </a:effectRef>
+          <a:fontRef idx="minor">
+            <a:schemeClr val="lt1"/>
+          </a:fontRef>
+        </p:style>
+        <p:txBody>
+          <a:bodyPr rtlCol="0" anchor="ctr"/>
+          <a:lstStyle/>
+          <a:p>
+            <a:pPr algn="ctr"/>
+          </a:p>
+        </p:txBody>
+      </p:sp>
+      <p:sp>
+        <p:nvSpPr>
+          <p:cNvPr id="3" name="Rectangle 2"/>
+          <p:cNvSpPr/>
+          <p:nvPr/>
+        </p:nvSpPr>
+        <p:spPr>
+          <a:xfrm>
+            <a:off x="4063898" y="0"/>
+            <a:ext cx="4063898" cy="45720"/>
+          </a:xfrm>
+          <a:prstGeom prst="rect">
+            <a:avLst/>
+          </a:prstGeom>
+          <a:solidFill>
+            <a:srgbClr val="BE8CFF"/>
+          </a:solidFill>
+          <a:ln>
+            <a:noFill/>
+          </a:ln>
+        </p:spPr>
+        <p:style>
+          <a:lnRef idx="1">
+            <a:schemeClr val="accent1"/>
+          </a:lnRef>
+          <a:fillRef idx="3">
+            <a:schemeClr val="accent1"/>
+          </a:fillRef>
+          <a:effectRef idx="2">
+            <a:schemeClr val="accent1"/>
+          </a:effectRef>
+          <a:fontRef idx="minor">
+            <a:schemeClr val="lt1"/>
+          </a:fontRef>
+        </p:style>
+        <p:txBody>
+          <a:bodyPr rtlCol="0" anchor="ctr"/>
+          <a:lstStyle/>
+          <a:p>
+            <a:pPr algn="ctr"/>
+          </a:p>
+        </p:txBody>
+      </p:sp>
+      <p:sp>
+        <p:nvSpPr>
+          <p:cNvPr id="4" name="Rectangle 3"/>
+          <p:cNvSpPr/>
+          <p:nvPr/>
+        </p:nvSpPr>
+        <p:spPr>
+          <a:xfrm>
+            <a:off x="8127796" y="0"/>
+            <a:ext cx="4063898" cy="45720"/>
+          </a:xfrm>
+          <a:prstGeom prst="rect">
+            <a:avLst/>
+          </a:prstGeom>
+          <a:solidFill>
+            <a:srgbClr val="00E6FF"/>
+          </a:solidFill>
+          <a:ln>
+            <a:noFill/>
+          </a:ln>
+        </p:spPr>
+        <p:style>
+          <a:lnRef idx="1">
+            <a:schemeClr val="accent1"/>
+          </a:lnRef>
+          <a:fillRef idx="3">
+            <a:schemeClr val="accent1"/>
+          </a:fillRef>
+          <a:effectRef idx="2">
+            <a:schemeClr val="accent1"/>
+          </a:effectRef>
+          <a:fontRef idx="minor">
+            <a:schemeClr val="lt1"/>
+          </a:fontRef>
+        </p:style>
+        <p:txBody>
+          <a:bodyPr rtlCol="0" anchor="ctr"/>
+          <a:lstStyle/>
+          <a:p>
+            <a:pPr algn="ctr"/>
+          </a:p>
+        </p:txBody>
+      </p:sp>
+      <p:sp>
+        <p:nvSpPr>
+          <p:cNvPr id="5" name="TextBox 4"/>
+          <p:cNvSpPr txBox="1"/>
+          <p:nvPr/>
+        </p:nvSpPr>
+        <p:spPr>
+          <a:xfrm>
+            <a:off x="914400" y="457200"/>
+            <a:ext cx="10362895" cy="914400"/>
+          </a:xfrm>
+          <a:prstGeom prst="rect">
+            <a:avLst/>
+          </a:prstGeom>
+          <a:noFill/>
+        </p:spPr>
+        <p:txBody>
+          <a:bodyPr wrap="none">
+            <a:spAutoFit/>
+          </a:bodyPr>
+          <a:lstStyle/>
+          <a:p>
+            <a:pPr algn="l">
+              <a:defRPr sz="4000" b="1">
+                <a:solidFill>
+                  <a:srgbClr val="F8F9FA"/>
+                </a:solidFill>
+                <a:latin typeface="Google Sans"/>
               </a:defRPr>
             </a:pPr>
             <a:r>
-              <a:t>5. Innovation: Why Local Lens Stands Out</a:t>
-            </a:r>
-          </a:p>
-        </p:txBody>
-      </p:sp>
-      <p:sp>
-        <p:nvSpPr>
-          <p:cNvPr id="3" name="Content Placeholder 2"/>
-          <p:cNvSpPr>
-            <a:spLocks noGrp="1"/>
-          </p:cNvSpPr>
-          <p:nvPr>
-            <p:ph idx="1"/>
-          </p:nvPr>
-        </p:nvSpPr>
-        <p:spPr/>
-        <p:txBody>
-          <a:bodyPr/>
-          <a:lstStyle/>
-          <a:p>
-            <a:pPr>
-              <a:defRPr sz="2000" b="1">
-                <a:solidFill>
-                  <a:srgbClr val="202124"/>
-                </a:solidFill>
-                <a:latin typeface="Arial"/>
+              <a:t>5. Innovation</a:t>
+            </a:r>
+          </a:p>
+        </p:txBody>
+      </p:sp>
+      <p:sp>
+        <p:nvSpPr>
+          <p:cNvPr id="6" name="Oval 5"/>
+          <p:cNvSpPr/>
+          <p:nvPr/>
+        </p:nvSpPr>
+        <p:spPr>
+          <a:xfrm>
+            <a:off x="548640" y="777240"/>
+            <a:ext cx="137160" cy="137160"/>
+          </a:xfrm>
+          <a:prstGeom prst="ellipse">
+            <a:avLst/>
+          </a:prstGeom>
+          <a:solidFill>
+            <a:srgbClr val="FF8AB3"/>
+          </a:solidFill>
+          <a:ln>
+            <a:noFill/>
+          </a:ln>
+        </p:spPr>
+        <p:style>
+          <a:lnRef idx="1">
+            <a:schemeClr val="accent1"/>
+          </a:lnRef>
+          <a:fillRef idx="3">
+            <a:schemeClr val="accent1"/>
+          </a:fillRef>
+          <a:effectRef idx="2">
+            <a:schemeClr val="accent1"/>
+          </a:effectRef>
+          <a:fontRef idx="minor">
+            <a:schemeClr val="lt1"/>
+          </a:fontRef>
+        </p:style>
+        <p:txBody>
+          <a:bodyPr rtlCol="0" anchor="ctr"/>
+          <a:lstStyle/>
+          <a:p>
+            <a:pPr algn="ctr"/>
+          </a:p>
+        </p:txBody>
+      </p:sp>
+      <p:sp>
+        <p:nvSpPr>
+          <p:cNvPr id="7" name="Rounded Rectangle 6"/>
+          <p:cNvSpPr/>
+          <p:nvPr/>
+        </p:nvSpPr>
+        <p:spPr>
+          <a:xfrm>
+            <a:off x="914400" y="1645920"/>
+            <a:ext cx="10362895" cy="4572000"/>
+          </a:xfrm>
+          <a:prstGeom prst="roundRect">
+            <a:avLst/>
+          </a:prstGeom>
+          <a:solidFill>
+            <a:srgbClr val="141A28"/>
+          </a:solidFill>
+          <a:ln w="12700">
+            <a:solidFill>
+              <a:srgbClr val="283041"/>
+            </a:solidFill>
+          </a:ln>
+        </p:spPr>
+        <p:style>
+          <a:lnRef idx="1">
+            <a:schemeClr val="accent1"/>
+          </a:lnRef>
+          <a:fillRef idx="3">
+            <a:schemeClr val="accent1"/>
+          </a:fillRef>
+          <a:effectRef idx="2">
+            <a:schemeClr val="accent1"/>
+          </a:effectRef>
+          <a:fontRef idx="minor">
+            <a:schemeClr val="lt1"/>
+          </a:fontRef>
+        </p:style>
+        <p:txBody>
+          <a:bodyPr rtlCol="0" anchor="ctr" wrap="square" lIns="457200" rIns="457200" tIns="457200"/>
+          <a:lstStyle/>
+          <a:p>
+            <a:pPr algn="ctr">
+              <a:defRPr sz="2800" b="1">
+                <a:solidFill>
+                  <a:srgbClr val="FF8AB3"/>
+                </a:solidFill>
+                <a:latin typeface="Google Sans"/>
               </a:defRPr>
             </a:pPr>
             <a:r>
@@ -3778,11 +5057,14 @@
           </a:p>
           <a:p>
             <a:pPr lvl="1">
-              <a:defRPr sz="1800" b="0">
-                <a:solidFill>
-                  <a:srgbClr val="202124"/>
-                </a:solidFill>
-                <a:latin typeface="Arial"/>
+              <a:spcBef>
+                <a:spcPts val="1200"/>
+              </a:spcBef>
+              <a:defRPr sz="2200">
+                <a:solidFill>
+                  <a:srgbClr val="A8B0B9"/>
+                </a:solidFill>
+                <a:latin typeface="Google Sans"/>
               </a:defRPr>
             </a:pPr>
             <a:r>
@@ -3791,11 +5073,14 @@
           </a:p>
           <a:p>
             <a:pPr lvl="1">
-              <a:defRPr sz="1800" b="0">
-                <a:solidFill>
-                  <a:srgbClr val="202124"/>
-                </a:solidFill>
-                <a:latin typeface="Arial"/>
+              <a:spcBef>
+                <a:spcPts val="1200"/>
+              </a:spcBef>
+              <a:defRPr sz="2200">
+                <a:solidFill>
+                  <a:srgbClr val="A8B0B9"/>
+                </a:solidFill>
+                <a:latin typeface="Google Sans"/>
               </a:defRPr>
             </a:pPr>
             <a:r>
@@ -3804,11 +5089,14 @@
           </a:p>
           <a:p>
             <a:pPr lvl="1">
-              <a:defRPr sz="1800" b="0">
-                <a:solidFill>
-                  <a:srgbClr val="202124"/>
-                </a:solidFill>
-                <a:latin typeface="Arial"/>
+              <a:spcBef>
+                <a:spcPts val="1200"/>
+              </a:spcBef>
+              <a:defRPr sz="2200">
+                <a:solidFill>
+                  <a:srgbClr val="A8B0B9"/>
+                </a:solidFill>
+                <a:latin typeface="Google Sans"/>
               </a:defRPr>
             </a:pPr>
             <a:r>
@@ -3828,6 +5116,14 @@
 <file path=ppt/slides/slide7.xml><?xml version="1.0" encoding="utf-8"?>
 <p:sld xmlns:a="http://schemas.openxmlformats.org/drawingml/2006/main" xmlns:p="http://schemas.openxmlformats.org/presentationml/2006/main" xmlns:r="http://schemas.openxmlformats.org/officeDocument/2006/relationships">
   <p:cSld>
+    <p:bg>
+      <p:bgPr>
+        <a:solidFill>
+          <a:srgbClr val="0B0F19"/>
+        </a:solidFill>
+        <a:effectLst/>
+      </p:bgPr>
+    </p:bg>
     <p:spTree>
       <p:nvGrpSpPr>
         <p:cNvPr id="1" name=""/>
@@ -3837,54 +5133,259 @@
       <p:grpSpPr/>
       <p:sp>
         <p:nvSpPr>
-          <p:cNvPr id="2" name="Title 1"/>
-          <p:cNvSpPr>
-            <a:spLocks noGrp="1"/>
-          </p:cNvSpPr>
-          <p:nvPr>
-            <p:ph type="title"/>
-          </p:nvPr>
-        </p:nvSpPr>
-        <p:spPr/>
-        <p:txBody>
-          <a:bodyPr/>
-          <a:lstStyle/>
-          <a:p>
-            <a:pPr>
-              <a:defRPr sz="3600" b="1">
-                <a:solidFill>
-                  <a:srgbClr val="4285F4"/>
-                </a:solidFill>
-                <a:latin typeface="Arial"/>
+          <p:cNvPr id="2" name="Rectangle 1"/>
+          <p:cNvSpPr/>
+          <p:nvPr/>
+        </p:nvSpPr>
+        <p:spPr>
+          <a:xfrm>
+            <a:off x="0" y="0"/>
+            <a:ext cx="4063898" cy="45720"/>
+          </a:xfrm>
+          <a:prstGeom prst="rect">
+            <a:avLst/>
+          </a:prstGeom>
+          <a:solidFill>
+            <a:srgbClr val="6AB0F3"/>
+          </a:solidFill>
+          <a:ln>
+            <a:noFill/>
+          </a:ln>
+        </p:spPr>
+        <p:style>
+          <a:lnRef idx="1">
+            <a:schemeClr val="accent1"/>
+          </a:lnRef>
+          <a:fillRef idx="3">
+            <a:schemeClr val="accent1"/>
+          </a:fillRef>
+          <a:effectRef idx="2">
+            <a:schemeClr val="accent1"/>
+          </a:effectRef>
+          <a:fontRef idx="minor">
+            <a:schemeClr val="lt1"/>
+          </a:fontRef>
+        </p:style>
+        <p:txBody>
+          <a:bodyPr rtlCol="0" anchor="ctr"/>
+          <a:lstStyle/>
+          <a:p>
+            <a:pPr algn="ctr"/>
+          </a:p>
+        </p:txBody>
+      </p:sp>
+      <p:sp>
+        <p:nvSpPr>
+          <p:cNvPr id="3" name="Rectangle 2"/>
+          <p:cNvSpPr/>
+          <p:nvPr/>
+        </p:nvSpPr>
+        <p:spPr>
+          <a:xfrm>
+            <a:off x="4063898" y="0"/>
+            <a:ext cx="4063898" cy="45720"/>
+          </a:xfrm>
+          <a:prstGeom prst="rect">
+            <a:avLst/>
+          </a:prstGeom>
+          <a:solidFill>
+            <a:srgbClr val="BE8CFF"/>
+          </a:solidFill>
+          <a:ln>
+            <a:noFill/>
+          </a:ln>
+        </p:spPr>
+        <p:style>
+          <a:lnRef idx="1">
+            <a:schemeClr val="accent1"/>
+          </a:lnRef>
+          <a:fillRef idx="3">
+            <a:schemeClr val="accent1"/>
+          </a:fillRef>
+          <a:effectRef idx="2">
+            <a:schemeClr val="accent1"/>
+          </a:effectRef>
+          <a:fontRef idx="minor">
+            <a:schemeClr val="lt1"/>
+          </a:fontRef>
+        </p:style>
+        <p:txBody>
+          <a:bodyPr rtlCol="0" anchor="ctr"/>
+          <a:lstStyle/>
+          <a:p>
+            <a:pPr algn="ctr"/>
+          </a:p>
+        </p:txBody>
+      </p:sp>
+      <p:sp>
+        <p:nvSpPr>
+          <p:cNvPr id="4" name="Rectangle 3"/>
+          <p:cNvSpPr/>
+          <p:nvPr/>
+        </p:nvSpPr>
+        <p:spPr>
+          <a:xfrm>
+            <a:off x="8127796" y="0"/>
+            <a:ext cx="4063898" cy="45720"/>
+          </a:xfrm>
+          <a:prstGeom prst="rect">
+            <a:avLst/>
+          </a:prstGeom>
+          <a:solidFill>
+            <a:srgbClr val="00E6FF"/>
+          </a:solidFill>
+          <a:ln>
+            <a:noFill/>
+          </a:ln>
+        </p:spPr>
+        <p:style>
+          <a:lnRef idx="1">
+            <a:schemeClr val="accent1"/>
+          </a:lnRef>
+          <a:fillRef idx="3">
+            <a:schemeClr val="accent1"/>
+          </a:fillRef>
+          <a:effectRef idx="2">
+            <a:schemeClr val="accent1"/>
+          </a:effectRef>
+          <a:fontRef idx="minor">
+            <a:schemeClr val="lt1"/>
+          </a:fontRef>
+        </p:style>
+        <p:txBody>
+          <a:bodyPr rtlCol="0" anchor="ctr"/>
+          <a:lstStyle/>
+          <a:p>
+            <a:pPr algn="ctr"/>
+          </a:p>
+        </p:txBody>
+      </p:sp>
+      <p:sp>
+        <p:nvSpPr>
+          <p:cNvPr id="5" name="TextBox 4"/>
+          <p:cNvSpPr txBox="1"/>
+          <p:nvPr/>
+        </p:nvSpPr>
+        <p:spPr>
+          <a:xfrm>
+            <a:off x="914400" y="457200"/>
+            <a:ext cx="10362895" cy="914400"/>
+          </a:xfrm>
+          <a:prstGeom prst="rect">
+            <a:avLst/>
+          </a:prstGeom>
+          <a:noFill/>
+        </p:spPr>
+        <p:txBody>
+          <a:bodyPr wrap="none">
+            <a:spAutoFit/>
+          </a:bodyPr>
+          <a:lstStyle/>
+          <a:p>
+            <a:pPr algn="l">
+              <a:defRPr sz="4000" b="1">
+                <a:solidFill>
+                  <a:srgbClr val="F8F9FA"/>
+                </a:solidFill>
+                <a:latin typeface="Google Sans"/>
               </a:defRPr>
             </a:pPr>
             <a:r>
-              <a:t>6. Core Features at a Glance</a:t>
-            </a:r>
-          </a:p>
-        </p:txBody>
-      </p:sp>
-      <p:sp>
-        <p:nvSpPr>
-          <p:cNvPr id="3" name="Content Placeholder 2"/>
-          <p:cNvSpPr>
-            <a:spLocks noGrp="1"/>
-          </p:cNvSpPr>
-          <p:nvPr>
-            <p:ph idx="1"/>
-          </p:nvPr>
-        </p:nvSpPr>
-        <p:spPr/>
-        <p:txBody>
-          <a:bodyPr/>
-          <a:lstStyle/>
-          <a:p>
-            <a:pPr>
-              <a:defRPr sz="2000" b="1">
-                <a:solidFill>
-                  <a:srgbClr val="202124"/>
-                </a:solidFill>
-                <a:latin typeface="Arial"/>
+              <a:t>6. Core Features</a:t>
+            </a:r>
+          </a:p>
+        </p:txBody>
+      </p:sp>
+      <p:sp>
+        <p:nvSpPr>
+          <p:cNvPr id="6" name="Oval 5"/>
+          <p:cNvSpPr/>
+          <p:nvPr/>
+        </p:nvSpPr>
+        <p:spPr>
+          <a:xfrm>
+            <a:off x="548640" y="777240"/>
+            <a:ext cx="137160" cy="137160"/>
+          </a:xfrm>
+          <a:prstGeom prst="ellipse">
+            <a:avLst/>
+          </a:prstGeom>
+          <a:solidFill>
+            <a:srgbClr val="00E6FF"/>
+          </a:solidFill>
+          <a:ln>
+            <a:noFill/>
+          </a:ln>
+        </p:spPr>
+        <p:style>
+          <a:lnRef idx="1">
+            <a:schemeClr val="accent1"/>
+          </a:lnRef>
+          <a:fillRef idx="3">
+            <a:schemeClr val="accent1"/>
+          </a:fillRef>
+          <a:effectRef idx="2">
+            <a:schemeClr val="accent1"/>
+          </a:effectRef>
+          <a:fontRef idx="minor">
+            <a:schemeClr val="lt1"/>
+          </a:fontRef>
+        </p:style>
+        <p:txBody>
+          <a:bodyPr rtlCol="0" anchor="ctr"/>
+          <a:lstStyle/>
+          <a:p>
+            <a:pPr algn="ctr"/>
+          </a:p>
+        </p:txBody>
+      </p:sp>
+      <p:sp>
+        <p:nvSpPr>
+          <p:cNvPr id="7" name="Rounded Rectangle 6"/>
+          <p:cNvSpPr/>
+          <p:nvPr/>
+        </p:nvSpPr>
+        <p:spPr>
+          <a:xfrm>
+            <a:off x="914400" y="1645920"/>
+            <a:ext cx="10362895" cy="4572000"/>
+          </a:xfrm>
+          <a:prstGeom prst="roundRect">
+            <a:avLst/>
+          </a:prstGeom>
+          <a:solidFill>
+            <a:srgbClr val="141A28"/>
+          </a:solidFill>
+          <a:ln w="12700">
+            <a:solidFill>
+              <a:srgbClr val="283041"/>
+            </a:solidFill>
+          </a:ln>
+        </p:spPr>
+        <p:style>
+          <a:lnRef idx="1">
+            <a:schemeClr val="accent1"/>
+          </a:lnRef>
+          <a:fillRef idx="3">
+            <a:schemeClr val="accent1"/>
+          </a:fillRef>
+          <a:effectRef idx="2">
+            <a:schemeClr val="accent1"/>
+          </a:effectRef>
+          <a:fontRef idx="minor">
+            <a:schemeClr val="lt1"/>
+          </a:fontRef>
+        </p:style>
+        <p:txBody>
+          <a:bodyPr rtlCol="0" anchor="ctr" wrap="square" lIns="457200" rIns="457200" tIns="457200"/>
+          <a:lstStyle/>
+          <a:p>
+            <a:pPr algn="ctr">
+              <a:defRPr sz="2800" b="1">
+                <a:solidFill>
+                  <a:srgbClr val="00E6FF"/>
+                </a:solidFill>
+                <a:latin typeface="Google Sans"/>
               </a:defRPr>
             </a:pPr>
             <a:r>
@@ -3893,11 +5394,14 @@
           </a:p>
           <a:p>
             <a:pPr lvl="1">
-              <a:defRPr sz="1800" b="0">
-                <a:solidFill>
-                  <a:srgbClr val="202124"/>
-                </a:solidFill>
-                <a:latin typeface="Arial"/>
+              <a:spcBef>
+                <a:spcPts val="1200"/>
+              </a:spcBef>
+              <a:defRPr sz="2200">
+                <a:solidFill>
+                  <a:srgbClr val="A8B0B9"/>
+                </a:solidFill>
+                <a:latin typeface="Google Sans"/>
               </a:defRPr>
             </a:pPr>
             <a:r>
@@ -3906,11 +5410,14 @@
           </a:p>
           <a:p>
             <a:pPr lvl="1">
-              <a:defRPr sz="1800" b="0">
-                <a:solidFill>
-                  <a:srgbClr val="202124"/>
-                </a:solidFill>
-                <a:latin typeface="Arial"/>
+              <a:spcBef>
+                <a:spcPts val="1200"/>
+              </a:spcBef>
+              <a:defRPr sz="2200">
+                <a:solidFill>
+                  <a:srgbClr val="A8B0B9"/>
+                </a:solidFill>
+                <a:latin typeface="Google Sans"/>
               </a:defRPr>
             </a:pPr>
             <a:r>
@@ -3919,11 +5426,14 @@
           </a:p>
           <a:p>
             <a:pPr lvl="1">
-              <a:defRPr sz="1800" b="0">
-                <a:solidFill>
-                  <a:srgbClr val="202124"/>
-                </a:solidFill>
-                <a:latin typeface="Arial"/>
+              <a:spcBef>
+                <a:spcPts val="1200"/>
+              </a:spcBef>
+              <a:defRPr sz="2200">
+                <a:solidFill>
+                  <a:srgbClr val="A8B0B9"/>
+                </a:solidFill>
+                <a:latin typeface="Google Sans"/>
               </a:defRPr>
             </a:pPr>
             <a:r>
@@ -3932,11 +5442,14 @@
           </a:p>
           <a:p>
             <a:pPr lvl="1">
-              <a:defRPr sz="1800" b="0">
-                <a:solidFill>
-                  <a:srgbClr val="202124"/>
-                </a:solidFill>
-                <a:latin typeface="Arial"/>
+              <a:spcBef>
+                <a:spcPts val="1200"/>
+              </a:spcBef>
+              <a:defRPr sz="2200">
+                <a:solidFill>
+                  <a:srgbClr val="A8B0B9"/>
+                </a:solidFill>
+                <a:latin typeface="Google Sans"/>
               </a:defRPr>
             </a:pPr>
             <a:r>
@@ -3956,6 +5469,14 @@
 <file path=ppt/slides/slide8.xml><?xml version="1.0" encoding="utf-8"?>
 <p:sld xmlns:a="http://schemas.openxmlformats.org/drawingml/2006/main" xmlns:p="http://schemas.openxmlformats.org/presentationml/2006/main" xmlns:r="http://schemas.openxmlformats.org/officeDocument/2006/relationships">
   <p:cSld>
+    <p:bg>
+      <p:bgPr>
+        <a:solidFill>
+          <a:srgbClr val="0B0F19"/>
+        </a:solidFill>
+        <a:effectLst/>
+      </p:bgPr>
+    </p:bg>
     <p:spTree>
       <p:nvGrpSpPr>
         <p:cNvPr id="1" name=""/>
@@ -3965,25 +5486,161 @@
       <p:grpSpPr/>
       <p:sp>
         <p:nvSpPr>
-          <p:cNvPr id="2" name="Title 1"/>
-          <p:cNvSpPr>
-            <a:spLocks noGrp="1"/>
-          </p:cNvSpPr>
-          <p:nvPr>
-            <p:ph type="title"/>
-          </p:nvPr>
-        </p:nvSpPr>
-        <p:spPr/>
-        <p:txBody>
-          <a:bodyPr/>
-          <a:lstStyle/>
-          <a:p>
-            <a:pPr>
-              <a:defRPr sz="3600" b="1">
-                <a:solidFill>
-                  <a:srgbClr val="4285F4"/>
-                </a:solidFill>
-                <a:latin typeface="Arial"/>
+          <p:cNvPr id="2" name="Rectangle 1"/>
+          <p:cNvSpPr/>
+          <p:nvPr/>
+        </p:nvSpPr>
+        <p:spPr>
+          <a:xfrm>
+            <a:off x="0" y="0"/>
+            <a:ext cx="4063898" cy="45720"/>
+          </a:xfrm>
+          <a:prstGeom prst="rect">
+            <a:avLst/>
+          </a:prstGeom>
+          <a:solidFill>
+            <a:srgbClr val="6AB0F3"/>
+          </a:solidFill>
+          <a:ln>
+            <a:noFill/>
+          </a:ln>
+        </p:spPr>
+        <p:style>
+          <a:lnRef idx="1">
+            <a:schemeClr val="accent1"/>
+          </a:lnRef>
+          <a:fillRef idx="3">
+            <a:schemeClr val="accent1"/>
+          </a:fillRef>
+          <a:effectRef idx="2">
+            <a:schemeClr val="accent1"/>
+          </a:effectRef>
+          <a:fontRef idx="minor">
+            <a:schemeClr val="lt1"/>
+          </a:fontRef>
+        </p:style>
+        <p:txBody>
+          <a:bodyPr rtlCol="0" anchor="ctr"/>
+          <a:lstStyle/>
+          <a:p>
+            <a:pPr algn="ctr"/>
+          </a:p>
+        </p:txBody>
+      </p:sp>
+      <p:sp>
+        <p:nvSpPr>
+          <p:cNvPr id="3" name="Rectangle 2"/>
+          <p:cNvSpPr/>
+          <p:nvPr/>
+        </p:nvSpPr>
+        <p:spPr>
+          <a:xfrm>
+            <a:off x="4063898" y="0"/>
+            <a:ext cx="4063898" cy="45720"/>
+          </a:xfrm>
+          <a:prstGeom prst="rect">
+            <a:avLst/>
+          </a:prstGeom>
+          <a:solidFill>
+            <a:srgbClr val="BE8CFF"/>
+          </a:solidFill>
+          <a:ln>
+            <a:noFill/>
+          </a:ln>
+        </p:spPr>
+        <p:style>
+          <a:lnRef idx="1">
+            <a:schemeClr val="accent1"/>
+          </a:lnRef>
+          <a:fillRef idx="3">
+            <a:schemeClr val="accent1"/>
+          </a:fillRef>
+          <a:effectRef idx="2">
+            <a:schemeClr val="accent1"/>
+          </a:effectRef>
+          <a:fontRef idx="minor">
+            <a:schemeClr val="lt1"/>
+          </a:fontRef>
+        </p:style>
+        <p:txBody>
+          <a:bodyPr rtlCol="0" anchor="ctr"/>
+          <a:lstStyle/>
+          <a:p>
+            <a:pPr algn="ctr"/>
+          </a:p>
+        </p:txBody>
+      </p:sp>
+      <p:sp>
+        <p:nvSpPr>
+          <p:cNvPr id="4" name="Rectangle 3"/>
+          <p:cNvSpPr/>
+          <p:nvPr/>
+        </p:nvSpPr>
+        <p:spPr>
+          <a:xfrm>
+            <a:off x="8127796" y="0"/>
+            <a:ext cx="4063898" cy="45720"/>
+          </a:xfrm>
+          <a:prstGeom prst="rect">
+            <a:avLst/>
+          </a:prstGeom>
+          <a:solidFill>
+            <a:srgbClr val="00E6FF"/>
+          </a:solidFill>
+          <a:ln>
+            <a:noFill/>
+          </a:ln>
+        </p:spPr>
+        <p:style>
+          <a:lnRef idx="1">
+            <a:schemeClr val="accent1"/>
+          </a:lnRef>
+          <a:fillRef idx="3">
+            <a:schemeClr val="accent1"/>
+          </a:fillRef>
+          <a:effectRef idx="2">
+            <a:schemeClr val="accent1"/>
+          </a:effectRef>
+          <a:fontRef idx="minor">
+            <a:schemeClr val="lt1"/>
+          </a:fontRef>
+        </p:style>
+        <p:txBody>
+          <a:bodyPr rtlCol="0" anchor="ctr"/>
+          <a:lstStyle/>
+          <a:p>
+            <a:pPr algn="ctr"/>
+          </a:p>
+        </p:txBody>
+      </p:sp>
+      <p:sp>
+        <p:nvSpPr>
+          <p:cNvPr id="5" name="TextBox 4"/>
+          <p:cNvSpPr txBox="1"/>
+          <p:nvPr/>
+        </p:nvSpPr>
+        <p:spPr>
+          <a:xfrm>
+            <a:off x="914400" y="457200"/>
+            <a:ext cx="10362895" cy="914400"/>
+          </a:xfrm>
+          <a:prstGeom prst="rect">
+            <a:avLst/>
+          </a:prstGeom>
+          <a:noFill/>
+        </p:spPr>
+        <p:txBody>
+          <a:bodyPr wrap="none">
+            <a:spAutoFit/>
+          </a:bodyPr>
+          <a:lstStyle/>
+          <a:p>
+            <a:pPr algn="l">
+              <a:defRPr sz="4000" b="1">
+                <a:solidFill>
+                  <a:srgbClr val="F8F9FA"/>
+                </a:solidFill>
+                <a:latin typeface="Google Sans"/>
               </a:defRPr>
             </a:pPr>
             <a:r>
@@ -3994,25 +5651,94 @@
       </p:sp>
       <p:sp>
         <p:nvSpPr>
-          <p:cNvPr id="3" name="Content Placeholder 2"/>
-          <p:cNvSpPr>
-            <a:spLocks noGrp="1"/>
-          </p:cNvSpPr>
-          <p:nvPr>
-            <p:ph idx="1"/>
-          </p:nvPr>
-        </p:nvSpPr>
-        <p:spPr/>
-        <p:txBody>
-          <a:bodyPr/>
-          <a:lstStyle/>
-          <a:p>
-            <a:pPr>
-              <a:defRPr sz="2000" b="1">
-                <a:solidFill>
-                  <a:srgbClr val="202124"/>
-                </a:solidFill>
-                <a:latin typeface="Arial"/>
+          <p:cNvPr id="6" name="Oval 5"/>
+          <p:cNvSpPr/>
+          <p:nvPr/>
+        </p:nvSpPr>
+        <p:spPr>
+          <a:xfrm>
+            <a:off x="548640" y="777240"/>
+            <a:ext cx="137160" cy="137160"/>
+          </a:xfrm>
+          <a:prstGeom prst="ellipse">
+            <a:avLst/>
+          </a:prstGeom>
+          <a:solidFill>
+            <a:srgbClr val="6AB0F3"/>
+          </a:solidFill>
+          <a:ln>
+            <a:noFill/>
+          </a:ln>
+        </p:spPr>
+        <p:style>
+          <a:lnRef idx="1">
+            <a:schemeClr val="accent1"/>
+          </a:lnRef>
+          <a:fillRef idx="3">
+            <a:schemeClr val="accent1"/>
+          </a:fillRef>
+          <a:effectRef idx="2">
+            <a:schemeClr val="accent1"/>
+          </a:effectRef>
+          <a:fontRef idx="minor">
+            <a:schemeClr val="lt1"/>
+          </a:fontRef>
+        </p:style>
+        <p:txBody>
+          <a:bodyPr rtlCol="0" anchor="ctr"/>
+          <a:lstStyle/>
+          <a:p>
+            <a:pPr algn="ctr"/>
+          </a:p>
+        </p:txBody>
+      </p:sp>
+      <p:sp>
+        <p:nvSpPr>
+          <p:cNvPr id="7" name="Rounded Rectangle 6"/>
+          <p:cNvSpPr/>
+          <p:nvPr/>
+        </p:nvSpPr>
+        <p:spPr>
+          <a:xfrm>
+            <a:off x="914400" y="1645920"/>
+            <a:ext cx="10362895" cy="4572000"/>
+          </a:xfrm>
+          <a:prstGeom prst="roundRect">
+            <a:avLst/>
+          </a:prstGeom>
+          <a:solidFill>
+            <a:srgbClr val="141A28"/>
+          </a:solidFill>
+          <a:ln w="12700">
+            <a:solidFill>
+              <a:srgbClr val="283041"/>
+            </a:solidFill>
+          </a:ln>
+        </p:spPr>
+        <p:style>
+          <a:lnRef idx="1">
+            <a:schemeClr val="accent1"/>
+          </a:lnRef>
+          <a:fillRef idx="3">
+            <a:schemeClr val="accent1"/>
+          </a:fillRef>
+          <a:effectRef idx="2">
+            <a:schemeClr val="accent1"/>
+          </a:effectRef>
+          <a:fontRef idx="minor">
+            <a:schemeClr val="lt1"/>
+          </a:fontRef>
+        </p:style>
+        <p:txBody>
+          <a:bodyPr rtlCol="0" anchor="ctr" wrap="square" lIns="457200" rIns="457200" tIns="457200"/>
+          <a:lstStyle/>
+          <a:p>
+            <a:pPr algn="ctr">
+              <a:defRPr sz="2800" b="1">
+                <a:solidFill>
+                  <a:srgbClr val="6AB0F3"/>
+                </a:solidFill>
+                <a:latin typeface="Google Sans"/>
               </a:defRPr>
             </a:pPr>
             <a:r>
@@ -4021,11 +5747,14 @@
           </a:p>
           <a:p>
             <a:pPr lvl="1">
-              <a:defRPr sz="1800" b="0">
-                <a:solidFill>
-                  <a:srgbClr val="202124"/>
-                </a:solidFill>
-                <a:latin typeface="Arial"/>
+              <a:spcBef>
+                <a:spcPts val="1200"/>
+              </a:spcBef>
+              <a:defRPr sz="2200">
+                <a:solidFill>
+                  <a:srgbClr val="A8B0B9"/>
+                </a:solidFill>
+                <a:latin typeface="Google Sans"/>
               </a:defRPr>
             </a:pPr>
             <a:r>
@@ -4034,11 +5763,14 @@
           </a:p>
           <a:p>
             <a:pPr lvl="1">
-              <a:defRPr sz="1800" b="0">
-                <a:solidFill>
-                  <a:srgbClr val="202124"/>
-                </a:solidFill>
-                <a:latin typeface="Arial"/>
+              <a:spcBef>
+                <a:spcPts val="1200"/>
+              </a:spcBef>
+              <a:defRPr sz="2200">
+                <a:solidFill>
+                  <a:srgbClr val="A8B0B9"/>
+                </a:solidFill>
+                <a:latin typeface="Google Sans"/>
               </a:defRPr>
             </a:pPr>
             <a:r>
@@ -4047,11 +5779,14 @@
           </a:p>
           <a:p>
             <a:pPr lvl="1">
-              <a:defRPr sz="1800" b="0">
-                <a:solidFill>
-                  <a:srgbClr val="202124"/>
-                </a:solidFill>
-                <a:latin typeface="Arial"/>
+              <a:spcBef>
+                <a:spcPts val="1200"/>
+              </a:spcBef>
+              <a:defRPr sz="2200">
+                <a:solidFill>
+                  <a:srgbClr val="A8B0B9"/>
+                </a:solidFill>
+                <a:latin typeface="Google Sans"/>
               </a:defRPr>
             </a:pPr>
             <a:r>
@@ -4060,11 +5795,14 @@
           </a:p>
           <a:p>
             <a:pPr lvl="1">
-              <a:defRPr sz="1800" b="0">
-                <a:solidFill>
-                  <a:srgbClr val="202124"/>
-                </a:solidFill>
-                <a:latin typeface="Arial"/>
+              <a:spcBef>
+                <a:spcPts val="1200"/>
+              </a:spcBef>
+              <a:defRPr sz="2200">
+                <a:solidFill>
+                  <a:srgbClr val="A8B0B9"/>
+                </a:solidFill>
+                <a:latin typeface="Google Sans"/>
               </a:defRPr>
             </a:pPr>
             <a:r>
@@ -4073,11 +5811,14 @@
           </a:p>
           <a:p>
             <a:pPr lvl="1">
-              <a:defRPr sz="1800" b="0">
-                <a:solidFill>
-                  <a:srgbClr val="202124"/>
-                </a:solidFill>
-                <a:latin typeface="Arial"/>
+              <a:spcBef>
+                <a:spcPts val="1200"/>
+              </a:spcBef>
+              <a:defRPr sz="2200">
+                <a:solidFill>
+                  <a:srgbClr val="A8B0B9"/>
+                </a:solidFill>
+                <a:latin typeface="Google Sans"/>
               </a:defRPr>
             </a:pPr>
             <a:r>
@@ -4097,6 +5838,14 @@
 <file path=ppt/slides/slide9.xml><?xml version="1.0" encoding="utf-8"?>
 <p:sld xmlns:a="http://schemas.openxmlformats.org/drawingml/2006/main" xmlns:p="http://schemas.openxmlformats.org/presentationml/2006/main" xmlns:r="http://schemas.openxmlformats.org/officeDocument/2006/relationships">
   <p:cSld>
+    <p:bg>
+      <p:bgPr>
+        <a:solidFill>
+          <a:srgbClr val="0B0F19"/>
+        </a:solidFill>
+        <a:effectLst/>
+      </p:bgPr>
+    </p:bg>
     <p:spTree>
       <p:nvGrpSpPr>
         <p:cNvPr id="1" name=""/>
@@ -4106,25 +5855,161 @@
       <p:grpSpPr/>
       <p:sp>
         <p:nvSpPr>
-          <p:cNvPr id="2" name="Title 1"/>
-          <p:cNvSpPr>
-            <a:spLocks noGrp="1"/>
-          </p:cNvSpPr>
-          <p:nvPr>
-            <p:ph type="title"/>
-          </p:nvPr>
-        </p:nvSpPr>
-        <p:spPr/>
-        <p:txBody>
-          <a:bodyPr/>
-          <a:lstStyle/>
-          <a:p>
-            <a:pPr>
-              <a:defRPr sz="3600" b="1">
-                <a:solidFill>
-                  <a:srgbClr val="4285F4"/>
-                </a:solidFill>
-                <a:latin typeface="Arial"/>
+          <p:cNvPr id="2" name="Rectangle 1"/>
+          <p:cNvSpPr/>
+          <p:nvPr/>
+        </p:nvSpPr>
+        <p:spPr>
+          <a:xfrm>
+            <a:off x="0" y="0"/>
+            <a:ext cx="4063898" cy="45720"/>
+          </a:xfrm>
+          <a:prstGeom prst="rect">
+            <a:avLst/>
+          </a:prstGeom>
+          <a:solidFill>
+            <a:srgbClr val="6AB0F3"/>
+          </a:solidFill>
+          <a:ln>
+            <a:noFill/>
+          </a:ln>
+        </p:spPr>
+        <p:style>
+          <a:lnRef idx="1">
+            <a:schemeClr val="accent1"/>
+          </a:lnRef>
+          <a:fillRef idx="3">
+            <a:schemeClr val="accent1"/>
+          </a:fillRef>
+          <a:effectRef idx="2">
+            <a:schemeClr val="accent1"/>
+          </a:effectRef>
+          <a:fontRef idx="minor">
+            <a:schemeClr val="lt1"/>
+          </a:fontRef>
+        </p:style>
+        <p:txBody>
+          <a:bodyPr rtlCol="0" anchor="ctr"/>
+          <a:lstStyle/>
+          <a:p>
+            <a:pPr algn="ctr"/>
+          </a:p>
+        </p:txBody>
+      </p:sp>
+      <p:sp>
+        <p:nvSpPr>
+          <p:cNvPr id="3" name="Rectangle 2"/>
+          <p:cNvSpPr/>
+          <p:nvPr/>
+        </p:nvSpPr>
+        <p:spPr>
+          <a:xfrm>
+            <a:off x="4063898" y="0"/>
+            <a:ext cx="4063898" cy="45720"/>
+          </a:xfrm>
+          <a:prstGeom prst="rect">
+            <a:avLst/>
+          </a:prstGeom>
+          <a:solidFill>
+            <a:srgbClr val="BE8CFF"/>
+          </a:solidFill>
+          <a:ln>
+            <a:noFill/>
+          </a:ln>
+        </p:spPr>
+        <p:style>
+          <a:lnRef idx="1">
+            <a:schemeClr val="accent1"/>
+          </a:lnRef>
+          <a:fillRef idx="3">
+            <a:schemeClr val="accent1"/>
+          </a:fillRef>
+          <a:effectRef idx="2">
+            <a:schemeClr val="accent1"/>
+          </a:effectRef>
+          <a:fontRef idx="minor">
+            <a:schemeClr val="lt1"/>
+          </a:fontRef>
+        </p:style>
+        <p:txBody>
+          <a:bodyPr rtlCol="0" anchor="ctr"/>
+          <a:lstStyle/>
+          <a:p>
+            <a:pPr algn="ctr"/>
+          </a:p>
+        </p:txBody>
+      </p:sp>
+      <p:sp>
+        <p:nvSpPr>
+          <p:cNvPr id="4" name="Rectangle 3"/>
+          <p:cNvSpPr/>
+          <p:nvPr/>
+        </p:nvSpPr>
+        <p:spPr>
+          <a:xfrm>
+            <a:off x="8127796" y="0"/>
+            <a:ext cx="4063898" cy="45720"/>
+          </a:xfrm>
+          <a:prstGeom prst="rect">
+            <a:avLst/>
+          </a:prstGeom>
+          <a:solidFill>
+            <a:srgbClr val="00E6FF"/>
+          </a:solidFill>
+          <a:ln>
+            <a:noFill/>
+          </a:ln>
+        </p:spPr>
+        <p:style>
+          <a:lnRef idx="1">
+            <a:schemeClr val="accent1"/>
+          </a:lnRef>
+          <a:fillRef idx="3">
+            <a:schemeClr val="accent1"/>
+          </a:fillRef>
+          <a:effectRef idx="2">
+            <a:schemeClr val="accent1"/>
+          </a:effectRef>
+          <a:fontRef idx="minor">
+            <a:schemeClr val="lt1"/>
+          </a:fontRef>
+        </p:style>
+        <p:txBody>
+          <a:bodyPr rtlCol="0" anchor="ctr"/>
+          <a:lstStyle/>
+          <a:p>
+            <a:pPr algn="ctr"/>
+          </a:p>
+        </p:txBody>
+      </p:sp>
+      <p:sp>
+        <p:nvSpPr>
+          <p:cNvPr id="5" name="TextBox 4"/>
+          <p:cNvSpPr txBox="1"/>
+          <p:nvPr/>
+        </p:nvSpPr>
+        <p:spPr>
+          <a:xfrm>
+            <a:off x="914400" y="457200"/>
+            <a:ext cx="10362895" cy="914400"/>
+          </a:xfrm>
+          <a:prstGeom prst="rect">
+            <a:avLst/>
+          </a:prstGeom>
+          <a:noFill/>
+        </p:spPr>
+        <p:txBody>
+          <a:bodyPr wrap="none">
+            <a:spAutoFit/>
+          </a:bodyPr>
+          <a:lstStyle/>
+          <a:p>
+            <a:pPr algn="l">
+              <a:defRPr sz="4000" b="1">
+                <a:solidFill>
+                  <a:srgbClr val="F8F9FA"/>
+                </a:solidFill>
+                <a:latin typeface="Google Sans"/>
               </a:defRPr>
             </a:pPr>
             <a:r>
@@ -4135,25 +6020,94 @@
       </p:sp>
       <p:sp>
         <p:nvSpPr>
-          <p:cNvPr id="3" name="Content Placeholder 2"/>
-          <p:cNvSpPr>
-            <a:spLocks noGrp="1"/>
-          </p:cNvSpPr>
-          <p:nvPr>
-            <p:ph idx="1"/>
-          </p:nvPr>
-        </p:nvSpPr>
-        <p:spPr/>
-        <p:txBody>
-          <a:bodyPr/>
-          <a:lstStyle/>
-          <a:p>
-            <a:pPr>
-              <a:defRPr sz="2000" b="1">
-                <a:solidFill>
-                  <a:srgbClr val="202124"/>
-                </a:solidFill>
-                <a:latin typeface="Arial"/>
+          <p:cNvPr id="6" name="Oval 5"/>
+          <p:cNvSpPr/>
+          <p:nvPr/>
+        </p:nvSpPr>
+        <p:spPr>
+          <a:xfrm>
+            <a:off x="548640" y="777240"/>
+            <a:ext cx="137160" cy="137160"/>
+          </a:xfrm>
+          <a:prstGeom prst="ellipse">
+            <a:avLst/>
+          </a:prstGeom>
+          <a:solidFill>
+            <a:srgbClr val="BE8CFF"/>
+          </a:solidFill>
+          <a:ln>
+            <a:noFill/>
+          </a:ln>
+        </p:spPr>
+        <p:style>
+          <a:lnRef idx="1">
+            <a:schemeClr val="accent1"/>
+          </a:lnRef>
+          <a:fillRef idx="3">
+            <a:schemeClr val="accent1"/>
+          </a:fillRef>
+          <a:effectRef idx="2">
+            <a:schemeClr val="accent1"/>
+          </a:effectRef>
+          <a:fontRef idx="minor">
+            <a:schemeClr val="lt1"/>
+          </a:fontRef>
+        </p:style>
+        <p:txBody>
+          <a:bodyPr rtlCol="0" anchor="ctr"/>
+          <a:lstStyle/>
+          <a:p>
+            <a:pPr algn="ctr"/>
+          </a:p>
+        </p:txBody>
+      </p:sp>
+      <p:sp>
+        <p:nvSpPr>
+          <p:cNvPr id="7" name="Rounded Rectangle 6"/>
+          <p:cNvSpPr/>
+          <p:nvPr/>
+        </p:nvSpPr>
+        <p:spPr>
+          <a:xfrm>
+            <a:off x="914400" y="1645920"/>
+            <a:ext cx="10362895" cy="4572000"/>
+          </a:xfrm>
+          <a:prstGeom prst="roundRect">
+            <a:avLst/>
+          </a:prstGeom>
+          <a:solidFill>
+            <a:srgbClr val="141A28"/>
+          </a:solidFill>
+          <a:ln w="12700">
+            <a:solidFill>
+              <a:srgbClr val="283041"/>
+            </a:solidFill>
+          </a:ln>
+        </p:spPr>
+        <p:style>
+          <a:lnRef idx="1">
+            <a:schemeClr val="accent1"/>
+          </a:lnRef>
+          <a:fillRef idx="3">
+            <a:schemeClr val="accent1"/>
+          </a:fillRef>
+          <a:effectRef idx="2">
+            <a:schemeClr val="accent1"/>
+          </a:effectRef>
+          <a:fontRef idx="minor">
+            <a:schemeClr val="lt1"/>
+          </a:fontRef>
+        </p:style>
+        <p:txBody>
+          <a:bodyPr rtlCol="0" anchor="ctr" wrap="square" lIns="457200" rIns="457200" tIns="457200"/>
+          <a:lstStyle/>
+          <a:p>
+            <a:pPr algn="ctr">
+              <a:defRPr sz="2800" b="1">
+                <a:solidFill>
+                  <a:srgbClr val="BE8CFF"/>
+                </a:solidFill>
+                <a:latin typeface="Google Sans"/>
               </a:defRPr>
             </a:pPr>
             <a:r>
@@ -4162,11 +6116,14 @@
           </a:p>
           <a:p>
             <a:pPr lvl="1">
-              <a:defRPr sz="1800" b="0">
-                <a:solidFill>
-                  <a:srgbClr val="202124"/>
-                </a:solidFill>
-                <a:latin typeface="Arial"/>
+              <a:spcBef>
+                <a:spcPts val="1200"/>
+              </a:spcBef>
+              <a:defRPr sz="2200">
+                <a:solidFill>
+                  <a:srgbClr val="A8B0B9"/>
+                </a:solidFill>
+                <a:latin typeface="Google Sans"/>
               </a:defRPr>
             </a:pPr>
             <a:r>
@@ -4175,11 +6132,14 @@
           </a:p>
           <a:p>
             <a:pPr lvl="1">
-              <a:defRPr sz="1800" b="0">
-                <a:solidFill>
-                  <a:srgbClr val="202124"/>
-                </a:solidFill>
-                <a:latin typeface="Arial"/>
+              <a:spcBef>
+                <a:spcPts val="1200"/>
+              </a:spcBef>
+              <a:defRPr sz="2200">
+                <a:solidFill>
+                  <a:srgbClr val="A8B0B9"/>
+                </a:solidFill>
+                <a:latin typeface="Google Sans"/>
               </a:defRPr>
             </a:pPr>
             <a:r>
@@ -4188,11 +6148,14 @@
           </a:p>
           <a:p>
             <a:pPr lvl="1">
-              <a:defRPr sz="1800" b="0">
-                <a:solidFill>
-                  <a:srgbClr val="202124"/>
-                </a:solidFill>
-                <a:latin typeface="Arial"/>
+              <a:spcBef>
+                <a:spcPts val="1200"/>
+              </a:spcBef>
+              <a:defRPr sz="2200">
+                <a:solidFill>
+                  <a:srgbClr val="A8B0B9"/>
+                </a:solidFill>
+                <a:latin typeface="Google Sans"/>
               </a:defRPr>
             </a:pPr>
             <a:r>
@@ -4201,11 +6164,14 @@
           </a:p>
           <a:p>
             <a:pPr lvl="1">
-              <a:defRPr sz="1800" b="0">
-                <a:solidFill>
-                  <a:srgbClr val="202124"/>
-                </a:solidFill>
-                <a:latin typeface="Arial"/>
+              <a:spcBef>
+                <a:spcPts val="1200"/>
+              </a:spcBef>
+              <a:defRPr sz="2200">
+                <a:solidFill>
+                  <a:srgbClr val="A8B0B9"/>
+                </a:solidFill>
+                <a:latin typeface="Google Sans"/>
               </a:defRPr>
             </a:pPr>
             <a:r>

</xml_diff>

<commit_message>
fix: Address review gaps (PulseFeed images, schemas, unique ids, firestore)
</commit_message>
<xml_diff>
--- a/docs/Local_Lens_Pitch_Deck.pptx
+++ b/docs/Local_Lens_Pitch_Deck.pptx
@@ -3092,7 +3092,7 @@
     <p:bg>
       <p:bgPr>
         <a:solidFill>
-          <a:srgbClr val="0B0F19"/>
+          <a:srgbClr val="F8F9FA"/>
         </a:solidFill>
         <a:effectLst/>
       </p:bgPr>
@@ -3113,13 +3113,13 @@
         <p:spPr>
           <a:xfrm>
             <a:off x="0" y="0"/>
-            <a:ext cx="4063898" cy="45720"/>
+            <a:ext cx="3047923" cy="182880"/>
           </a:xfrm>
           <a:prstGeom prst="rect">
             <a:avLst/>
           </a:prstGeom>
           <a:solidFill>
-            <a:srgbClr val="6AB0F3"/>
+            <a:srgbClr val="4285F4"/>
           </a:solidFill>
           <a:ln>
             <a:noFill/>
@@ -3155,14 +3155,14 @@
         </p:nvSpPr>
         <p:spPr>
           <a:xfrm>
-            <a:off x="4063898" y="0"/>
-            <a:ext cx="4063898" cy="45720"/>
+            <a:off x="3047923" y="0"/>
+            <a:ext cx="3047923" cy="182880"/>
           </a:xfrm>
           <a:prstGeom prst="rect">
             <a:avLst/>
           </a:prstGeom>
           <a:solidFill>
-            <a:srgbClr val="BE8CFF"/>
+            <a:srgbClr val="EA4335"/>
           </a:solidFill>
           <a:ln>
             <a:noFill/>
@@ -3198,14 +3198,14 @@
         </p:nvSpPr>
         <p:spPr>
           <a:xfrm>
-            <a:off x="8127796" y="0"/>
-            <a:ext cx="4063898" cy="45720"/>
+            <a:off x="6095847" y="0"/>
+            <a:ext cx="3047923" cy="182880"/>
           </a:xfrm>
           <a:prstGeom prst="rect">
             <a:avLst/>
           </a:prstGeom>
           <a:solidFill>
-            <a:srgbClr val="00E6FF"/>
+            <a:srgbClr val="FBBC05"/>
           </a:solidFill>
           <a:ln>
             <a:noFill/>
@@ -3235,20 +3235,20 @@
       </p:sp>
       <p:sp>
         <p:nvSpPr>
-          <p:cNvPr id="5" name="Oval 4"/>
+          <p:cNvPr id="5" name="Rectangle 4"/>
           <p:cNvSpPr/>
           <p:nvPr/>
         </p:nvSpPr>
         <p:spPr>
           <a:xfrm>
-            <a:off x="4114800" y="914400"/>
-            <a:ext cx="3962095" cy="3962095"/>
+            <a:off x="9143771" y="0"/>
+            <a:ext cx="3047923" cy="182880"/>
           </a:xfrm>
-          <a:prstGeom prst="ellipse">
+          <a:prstGeom prst="rect">
             <a:avLst/>
           </a:prstGeom>
           <a:solidFill>
-            <a:srgbClr val="12182D"/>
+            <a:srgbClr val="34A853"/>
           </a:solidFill>
           <a:ln>
             <a:noFill/>
@@ -3278,14 +3278,83 @@
       </p:sp>
       <p:sp>
         <p:nvSpPr>
-          <p:cNvPr id="6" name="TextBox 5"/>
+          <p:cNvPr id="6" name="Rounded Rectangle 5"/>
+          <p:cNvSpPr/>
+          <p:nvPr/>
+        </p:nvSpPr>
+        <p:spPr>
+          <a:xfrm>
+            <a:off x="1371600" y="1828800"/>
+            <a:ext cx="9448495" cy="3200400"/>
+          </a:xfrm>
+          <a:prstGeom prst="roundRect">
+            <a:avLst/>
+          </a:prstGeom>
+          <a:solidFill>
+            <a:srgbClr val="FFFFFF"/>
+          </a:solidFill>
+          <a:ln w="12700">
+            <a:solidFill>
+              <a:srgbClr val="C4C7C5"/>
+            </a:solidFill>
+          </a:ln>
+        </p:spPr>
+        <p:style>
+          <a:lnRef idx="1">
+            <a:schemeClr val="accent1"/>
+          </a:lnRef>
+          <a:fillRef idx="3">
+            <a:schemeClr val="accent1"/>
+          </a:fillRef>
+          <a:effectRef idx="2">
+            <a:schemeClr val="accent1"/>
+          </a:effectRef>
+          <a:fontRef idx="minor">
+            <a:schemeClr val="lt1"/>
+          </a:fontRef>
+        </p:style>
+        <p:txBody>
+          <a:bodyPr rtlCol="0" anchor="ctr"/>
+          <a:lstStyle/>
+          <a:p>
+            <a:pPr algn="ctr">
+              <a:defRPr sz="6400" b="1">
+                <a:solidFill>
+                  <a:srgbClr val="1F1F1F"/>
+                </a:solidFill>
+                <a:latin typeface="Google Sans"/>
+              </a:defRPr>
+            </a:pPr>
+            <a:r>
+              <a:t>Local Lens</a:t>
+            </a:r>
+          </a:p>
+          <a:p>
+            <a:br/>
+            <a:pPr algn="ctr">
+              <a:defRPr sz="2400">
+                <a:solidFill>
+                  <a:srgbClr val="444746"/>
+                </a:solidFill>
+                <a:latin typeface="Roboto"/>
+              </a:defRPr>
+            </a:pPr>
+            <a:r>
+              <a:t>Hyperlocalized Context Builder from Everyday Photos</a:t>
+            </a:r>
+          </a:p>
+        </p:txBody>
+      </p:sp>
+      <p:sp>
+        <p:nvSpPr>
+          <p:cNvPr id="7" name="TextBox 6"/>
           <p:cNvSpPr txBox="1"/>
           <p:nvPr/>
         </p:nvSpPr>
         <p:spPr>
           <a:xfrm>
-            <a:off x="914400" y="2011680"/>
-            <a:ext cx="10362895" cy="1371600"/>
+            <a:off x="1371600" y="5486400"/>
+            <a:ext cx="9448495" cy="914400"/>
           </a:xfrm>
           <a:prstGeom prst="rect">
             <a:avLst/>
@@ -3299,87 +3368,11 @@
           <a:lstStyle/>
           <a:p>
             <a:pPr algn="ctr">
-              <a:defRPr sz="7200" b="1">
-                <a:solidFill>
-                  <a:srgbClr val="F8F9FA"/>
-                </a:solidFill>
-                <a:latin typeface="Google Sans"/>
-              </a:defRPr>
-            </a:pPr>
-            <a:r>
-              <a:t>Local Lens</a:t>
-            </a:r>
-          </a:p>
-        </p:txBody>
-      </p:sp>
-      <p:sp>
-        <p:nvSpPr>
-          <p:cNvPr id="7" name="TextBox 6"/>
-          <p:cNvSpPr txBox="1"/>
-          <p:nvPr/>
-        </p:nvSpPr>
-        <p:spPr>
-          <a:xfrm>
-            <a:off x="914400" y="3657600"/>
-            <a:ext cx="10362895" cy="914400"/>
-          </a:xfrm>
-          <a:prstGeom prst="rect">
-            <a:avLst/>
-          </a:prstGeom>
-          <a:noFill/>
-        </p:spPr>
-        <p:txBody>
-          <a:bodyPr wrap="none">
-            <a:spAutoFit/>
-          </a:bodyPr>
-          <a:lstStyle/>
-          <a:p>
-            <a:pPr algn="ctr">
-              <a:defRPr sz="2800">
-                <a:solidFill>
-                  <a:srgbClr val="6AB0F3"/>
-                </a:solidFill>
-                <a:latin typeface="Google Sans"/>
-              </a:defRPr>
-            </a:pPr>
-            <a:r>
-              <a:t>Hyperlocalized Context Builder</a:t>
-            </a:r>
-            <a:br/>
-            <a:r>
-              <a:t>Powered by Gemini Advanced</a:t>
-            </a:r>
-          </a:p>
-        </p:txBody>
-      </p:sp>
-      <p:sp>
-        <p:nvSpPr>
-          <p:cNvPr id="8" name="TextBox 7"/>
-          <p:cNvSpPr txBox="1"/>
-          <p:nvPr/>
-        </p:nvSpPr>
-        <p:spPr>
-          <a:xfrm>
-            <a:off x="914400" y="5486400"/>
-            <a:ext cx="10362895" cy="914400"/>
-          </a:xfrm>
-          <a:prstGeom prst="rect">
-            <a:avLst/>
-          </a:prstGeom>
-          <a:noFill/>
-        </p:spPr>
-        <p:txBody>
-          <a:bodyPr wrap="none">
-            <a:spAutoFit/>
-          </a:bodyPr>
-          <a:lstStyle/>
-          <a:p>
-            <a:pPr algn="ctr">
               <a:defRPr sz="1800">
                 <a:solidFill>
-                  <a:srgbClr val="A8B0B9"/>
-                </a:solidFill>
-                <a:latin typeface="Google Sans"/>
+                  <a:srgbClr val="444746"/>
+                </a:solidFill>
+                <a:latin typeface="Roboto"/>
               </a:defRPr>
             </a:pPr>
             <a:r>
@@ -3402,7 +3395,7 @@
     <p:bg>
       <p:bgPr>
         <a:solidFill>
-          <a:srgbClr val="0B0F19"/>
+          <a:srgbClr val="F8F9FA"/>
         </a:solidFill>
         <a:effectLst/>
       </p:bgPr>
@@ -3423,13 +3416,13 @@
         <p:spPr>
           <a:xfrm>
             <a:off x="0" y="0"/>
-            <a:ext cx="4063898" cy="45720"/>
+            <a:ext cx="12191695" cy="182880"/>
           </a:xfrm>
           <a:prstGeom prst="rect">
             <a:avLst/>
           </a:prstGeom>
           <a:solidFill>
-            <a:srgbClr val="6AB0F3"/>
+            <a:srgbClr val="EA4335"/>
           </a:solidFill>
           <a:ln>
             <a:noFill/>
@@ -3459,99 +3452,13 @@
       </p:sp>
       <p:sp>
         <p:nvSpPr>
-          <p:cNvPr id="3" name="Rectangle 2"/>
-          <p:cNvSpPr/>
+          <p:cNvPr id="3" name="TextBox 2"/>
+          <p:cNvSpPr txBox="1"/>
           <p:nvPr/>
         </p:nvSpPr>
         <p:spPr>
           <a:xfrm>
-            <a:off x="4063898" y="0"/>
-            <a:ext cx="4063898" cy="45720"/>
-          </a:xfrm>
-          <a:prstGeom prst="rect">
-            <a:avLst/>
-          </a:prstGeom>
-          <a:solidFill>
-            <a:srgbClr val="BE8CFF"/>
-          </a:solidFill>
-          <a:ln>
-            <a:noFill/>
-          </a:ln>
-        </p:spPr>
-        <p:style>
-          <a:lnRef idx="1">
-            <a:schemeClr val="accent1"/>
-          </a:lnRef>
-          <a:fillRef idx="3">
-            <a:schemeClr val="accent1"/>
-          </a:fillRef>
-          <a:effectRef idx="2">
-            <a:schemeClr val="accent1"/>
-          </a:effectRef>
-          <a:fontRef idx="minor">
-            <a:schemeClr val="lt1"/>
-          </a:fontRef>
-        </p:style>
-        <p:txBody>
-          <a:bodyPr rtlCol="0" anchor="ctr"/>
-          <a:lstStyle/>
-          <a:p>
-            <a:pPr algn="ctr"/>
-          </a:p>
-        </p:txBody>
-      </p:sp>
-      <p:sp>
-        <p:nvSpPr>
-          <p:cNvPr id="4" name="Rectangle 3"/>
-          <p:cNvSpPr/>
-          <p:nvPr/>
-        </p:nvSpPr>
-        <p:spPr>
-          <a:xfrm>
-            <a:off x="8127796" y="0"/>
-            <a:ext cx="4063898" cy="45720"/>
-          </a:xfrm>
-          <a:prstGeom prst="rect">
-            <a:avLst/>
-          </a:prstGeom>
-          <a:solidFill>
-            <a:srgbClr val="00E6FF"/>
-          </a:solidFill>
-          <a:ln>
-            <a:noFill/>
-          </a:ln>
-        </p:spPr>
-        <p:style>
-          <a:lnRef idx="1">
-            <a:schemeClr val="accent1"/>
-          </a:lnRef>
-          <a:fillRef idx="3">
-            <a:schemeClr val="accent1"/>
-          </a:fillRef>
-          <a:effectRef idx="2">
-            <a:schemeClr val="accent1"/>
-          </a:effectRef>
-          <a:fontRef idx="minor">
-            <a:schemeClr val="lt1"/>
-          </a:fontRef>
-        </p:style>
-        <p:txBody>
-          <a:bodyPr rtlCol="0" anchor="ctr"/>
-          <a:lstStyle/>
-          <a:p>
-            <a:pPr algn="ctr"/>
-          </a:p>
-        </p:txBody>
-      </p:sp>
-      <p:sp>
-        <p:nvSpPr>
-          <p:cNvPr id="5" name="TextBox 4"/>
-          <p:cNvSpPr txBox="1"/>
-          <p:nvPr/>
-        </p:nvSpPr>
-        <p:spPr>
-          <a:xfrm>
-            <a:off x="914400" y="457200"/>
+            <a:off x="914400" y="548640"/>
             <a:ext cx="10362895" cy="914400"/>
           </a:xfrm>
           <a:prstGeom prst="rect">
@@ -3565,10 +3472,10 @@
           </a:bodyPr>
           <a:lstStyle/>
           <a:p>
-            <a:pPr algn="l">
-              <a:defRPr sz="4000" b="1">
-                <a:solidFill>
-                  <a:srgbClr val="F8F9FA"/>
+            <a:pPr>
+              <a:defRPr sz="4400">
+                <a:solidFill>
+                  <a:srgbClr val="1F1F1F"/>
                 </a:solidFill>
                 <a:latin typeface="Google Sans"/>
               </a:defRPr>
@@ -3581,50 +3488,7 @@
       </p:sp>
       <p:sp>
         <p:nvSpPr>
-          <p:cNvPr id="6" name="Oval 5"/>
-          <p:cNvSpPr/>
-          <p:nvPr/>
-        </p:nvSpPr>
-        <p:spPr>
-          <a:xfrm>
-            <a:off x="548640" y="777240"/>
-            <a:ext cx="137160" cy="137160"/>
-          </a:xfrm>
-          <a:prstGeom prst="ellipse">
-            <a:avLst/>
-          </a:prstGeom>
-          <a:solidFill>
-            <a:srgbClr val="FF8AB3"/>
-          </a:solidFill>
-          <a:ln>
-            <a:noFill/>
-          </a:ln>
-        </p:spPr>
-        <p:style>
-          <a:lnRef idx="1">
-            <a:schemeClr val="accent1"/>
-          </a:lnRef>
-          <a:fillRef idx="3">
-            <a:schemeClr val="accent1"/>
-          </a:fillRef>
-          <a:effectRef idx="2">
-            <a:schemeClr val="accent1"/>
-          </a:effectRef>
-          <a:fontRef idx="minor">
-            <a:schemeClr val="lt1"/>
-          </a:fontRef>
-        </p:style>
-        <p:txBody>
-          <a:bodyPr rtlCol="0" anchor="ctr"/>
-          <a:lstStyle/>
-          <a:p>
-            <a:pPr algn="ctr"/>
-          </a:p>
-        </p:txBody>
-      </p:sp>
-      <p:sp>
-        <p:nvSpPr>
-          <p:cNvPr id="7" name="Rounded Rectangle 6"/>
+          <p:cNvPr id="4" name="Rounded Rectangle 3"/>
           <p:cNvSpPr/>
           <p:nvPr/>
         </p:nvSpPr>
@@ -3637,11 +3501,11 @@
             <a:avLst/>
           </a:prstGeom>
           <a:solidFill>
-            <a:srgbClr val="141A28"/>
+            <a:srgbClr val="FFFFFF"/>
           </a:solidFill>
           <a:ln w="12700">
             <a:solidFill>
-              <a:srgbClr val="283041"/>
+              <a:srgbClr val="C4C7C5"/>
             </a:solidFill>
           </a:ln>
         </p:spPr>
@@ -3666,7 +3530,7 @@
             <a:pPr algn="ctr">
               <a:defRPr sz="2800" b="1">
                 <a:solidFill>
-                  <a:srgbClr val="FF8AB3"/>
+                  <a:srgbClr val="EA4335"/>
                 </a:solidFill>
                 <a:latin typeface="Google Sans"/>
               </a:defRPr>
@@ -3682,9 +3546,9 @@
               </a:spcBef>
               <a:defRPr sz="2200">
                 <a:solidFill>
-                  <a:srgbClr val="A8B0B9"/>
-                </a:solidFill>
-                <a:latin typeface="Google Sans"/>
+                  <a:srgbClr val="444746"/>
+                </a:solidFill>
+                <a:latin typeface="Roboto"/>
               </a:defRPr>
             </a:pPr>
             <a:r>
@@ -3698,9 +3562,9 @@
               </a:spcBef>
               <a:defRPr sz="2200">
                 <a:solidFill>
-                  <a:srgbClr val="A8B0B9"/>
-                </a:solidFill>
-                <a:latin typeface="Google Sans"/>
+                  <a:srgbClr val="444746"/>
+                </a:solidFill>
+                <a:latin typeface="Roboto"/>
               </a:defRPr>
             </a:pPr>
             <a:r>
@@ -3714,9 +3578,9 @@
               </a:spcBef>
               <a:defRPr sz="2200">
                 <a:solidFill>
-                  <a:srgbClr val="A8B0B9"/>
-                </a:solidFill>
-                <a:latin typeface="Google Sans"/>
+                  <a:srgbClr val="444746"/>
+                </a:solidFill>
+                <a:latin typeface="Roboto"/>
               </a:defRPr>
             </a:pPr>
             <a:r>
@@ -3739,7 +3603,7 @@
     <p:bg>
       <p:bgPr>
         <a:solidFill>
-          <a:srgbClr val="0B0F19"/>
+          <a:srgbClr val="F8F9FA"/>
         </a:solidFill>
         <a:effectLst/>
       </p:bgPr>
@@ -3760,13 +3624,13 @@
         <p:spPr>
           <a:xfrm>
             <a:off x="0" y="0"/>
-            <a:ext cx="4063898" cy="45720"/>
+            <a:ext cx="12191695" cy="182880"/>
           </a:xfrm>
           <a:prstGeom prst="rect">
             <a:avLst/>
           </a:prstGeom>
           <a:solidFill>
-            <a:srgbClr val="6AB0F3"/>
+            <a:srgbClr val="34A853"/>
           </a:solidFill>
           <a:ln>
             <a:noFill/>
@@ -3796,99 +3660,13 @@
       </p:sp>
       <p:sp>
         <p:nvSpPr>
-          <p:cNvPr id="3" name="Rectangle 2"/>
-          <p:cNvSpPr/>
+          <p:cNvPr id="3" name="TextBox 2"/>
+          <p:cNvSpPr txBox="1"/>
           <p:nvPr/>
         </p:nvSpPr>
         <p:spPr>
           <a:xfrm>
-            <a:off x="4063898" y="0"/>
-            <a:ext cx="4063898" cy="45720"/>
-          </a:xfrm>
-          <a:prstGeom prst="rect">
-            <a:avLst/>
-          </a:prstGeom>
-          <a:solidFill>
-            <a:srgbClr val="BE8CFF"/>
-          </a:solidFill>
-          <a:ln>
-            <a:noFill/>
-          </a:ln>
-        </p:spPr>
-        <p:style>
-          <a:lnRef idx="1">
-            <a:schemeClr val="accent1"/>
-          </a:lnRef>
-          <a:fillRef idx="3">
-            <a:schemeClr val="accent1"/>
-          </a:fillRef>
-          <a:effectRef idx="2">
-            <a:schemeClr val="accent1"/>
-          </a:effectRef>
-          <a:fontRef idx="minor">
-            <a:schemeClr val="lt1"/>
-          </a:fontRef>
-        </p:style>
-        <p:txBody>
-          <a:bodyPr rtlCol="0" anchor="ctr"/>
-          <a:lstStyle/>
-          <a:p>
-            <a:pPr algn="ctr"/>
-          </a:p>
-        </p:txBody>
-      </p:sp>
-      <p:sp>
-        <p:nvSpPr>
-          <p:cNvPr id="4" name="Rectangle 3"/>
-          <p:cNvSpPr/>
-          <p:nvPr/>
-        </p:nvSpPr>
-        <p:spPr>
-          <a:xfrm>
-            <a:off x="8127796" y="0"/>
-            <a:ext cx="4063898" cy="45720"/>
-          </a:xfrm>
-          <a:prstGeom prst="rect">
-            <a:avLst/>
-          </a:prstGeom>
-          <a:solidFill>
-            <a:srgbClr val="00E6FF"/>
-          </a:solidFill>
-          <a:ln>
-            <a:noFill/>
-          </a:ln>
-        </p:spPr>
-        <p:style>
-          <a:lnRef idx="1">
-            <a:schemeClr val="accent1"/>
-          </a:lnRef>
-          <a:fillRef idx="3">
-            <a:schemeClr val="accent1"/>
-          </a:fillRef>
-          <a:effectRef idx="2">
-            <a:schemeClr val="accent1"/>
-          </a:effectRef>
-          <a:fontRef idx="minor">
-            <a:schemeClr val="lt1"/>
-          </a:fontRef>
-        </p:style>
-        <p:txBody>
-          <a:bodyPr rtlCol="0" anchor="ctr"/>
-          <a:lstStyle/>
-          <a:p>
-            <a:pPr algn="ctr"/>
-          </a:p>
-        </p:txBody>
-      </p:sp>
-      <p:sp>
-        <p:nvSpPr>
-          <p:cNvPr id="5" name="TextBox 4"/>
-          <p:cNvSpPr txBox="1"/>
-          <p:nvPr/>
-        </p:nvSpPr>
-        <p:spPr>
-          <a:xfrm>
-            <a:off x="914400" y="457200"/>
+            <a:off x="914400" y="548640"/>
             <a:ext cx="10362895" cy="914400"/>
           </a:xfrm>
           <a:prstGeom prst="rect">
@@ -3902,10 +3680,10 @@
           </a:bodyPr>
           <a:lstStyle/>
           <a:p>
-            <a:pPr algn="l">
-              <a:defRPr sz="4000" b="1">
-                <a:solidFill>
-                  <a:srgbClr val="F8F9FA"/>
+            <a:pPr>
+              <a:defRPr sz="4400">
+                <a:solidFill>
+                  <a:srgbClr val="1F1F1F"/>
                 </a:solidFill>
                 <a:latin typeface="Google Sans"/>
               </a:defRPr>
@@ -3918,50 +3696,7 @@
       </p:sp>
       <p:sp>
         <p:nvSpPr>
-          <p:cNvPr id="6" name="Oval 5"/>
-          <p:cNvSpPr/>
-          <p:nvPr/>
-        </p:nvSpPr>
-        <p:spPr>
-          <a:xfrm>
-            <a:off x="548640" y="777240"/>
-            <a:ext cx="137160" cy="137160"/>
-          </a:xfrm>
-          <a:prstGeom prst="ellipse">
-            <a:avLst/>
-          </a:prstGeom>
-          <a:solidFill>
-            <a:srgbClr val="00E6FF"/>
-          </a:solidFill>
-          <a:ln>
-            <a:noFill/>
-          </a:ln>
-        </p:spPr>
-        <p:style>
-          <a:lnRef idx="1">
-            <a:schemeClr val="accent1"/>
-          </a:lnRef>
-          <a:fillRef idx="3">
-            <a:schemeClr val="accent1"/>
-          </a:fillRef>
-          <a:effectRef idx="2">
-            <a:schemeClr val="accent1"/>
-          </a:effectRef>
-          <a:fontRef idx="minor">
-            <a:schemeClr val="lt1"/>
-          </a:fontRef>
-        </p:style>
-        <p:txBody>
-          <a:bodyPr rtlCol="0" anchor="ctr"/>
-          <a:lstStyle/>
-          <a:p>
-            <a:pPr algn="ctr"/>
-          </a:p>
-        </p:txBody>
-      </p:sp>
-      <p:sp>
-        <p:nvSpPr>
-          <p:cNvPr id="7" name="Rounded Rectangle 6"/>
+          <p:cNvPr id="4" name="Rounded Rectangle 3"/>
           <p:cNvSpPr/>
           <p:nvPr/>
         </p:nvSpPr>
@@ -3974,11 +3709,11 @@
             <a:avLst/>
           </a:prstGeom>
           <a:solidFill>
-            <a:srgbClr val="141A28"/>
+            <a:srgbClr val="FFFFFF"/>
           </a:solidFill>
           <a:ln w="12700">
             <a:solidFill>
-              <a:srgbClr val="283041"/>
+              <a:srgbClr val="C4C7C5"/>
             </a:solidFill>
           </a:ln>
         </p:spPr>
@@ -4003,7 +3738,7 @@
             <a:pPr algn="ctr">
               <a:defRPr sz="2800" b="1">
                 <a:solidFill>
-                  <a:srgbClr val="00E6FF"/>
+                  <a:srgbClr val="34A853"/>
                 </a:solidFill>
                 <a:latin typeface="Google Sans"/>
               </a:defRPr>
@@ -4019,9 +3754,9 @@
               </a:spcBef>
               <a:defRPr sz="2200">
                 <a:solidFill>
-                  <a:srgbClr val="A8B0B9"/>
-                </a:solidFill>
-                <a:latin typeface="Google Sans"/>
+                  <a:srgbClr val="444746"/>
+                </a:solidFill>
+                <a:latin typeface="Roboto"/>
               </a:defRPr>
             </a:pPr>
             <a:r>
@@ -4035,9 +3770,9 @@
               </a:spcBef>
               <a:defRPr sz="2200">
                 <a:solidFill>
-                  <a:srgbClr val="A8B0B9"/>
-                </a:solidFill>
-                <a:latin typeface="Google Sans"/>
+                  <a:srgbClr val="444746"/>
+                </a:solidFill>
+                <a:latin typeface="Roboto"/>
               </a:defRPr>
             </a:pPr>
             <a:r>
@@ -4051,9 +3786,9 @@
               </a:spcBef>
               <a:defRPr sz="2200">
                 <a:solidFill>
-                  <a:srgbClr val="A8B0B9"/>
-                </a:solidFill>
-                <a:latin typeface="Google Sans"/>
+                  <a:srgbClr val="444746"/>
+                </a:solidFill>
+                <a:latin typeface="Roboto"/>
               </a:defRPr>
             </a:pPr>
             <a:r>
@@ -4076,7 +3811,7 @@
     <p:bg>
       <p:bgPr>
         <a:solidFill>
-          <a:srgbClr val="0B0F19"/>
+          <a:srgbClr val="F8F9FA"/>
         </a:solidFill>
         <a:effectLst/>
       </p:bgPr>
@@ -4097,13 +3832,13 @@
         <p:spPr>
           <a:xfrm>
             <a:off x="0" y="0"/>
-            <a:ext cx="4063898" cy="45720"/>
+            <a:ext cx="12191695" cy="182880"/>
           </a:xfrm>
           <a:prstGeom prst="rect">
             <a:avLst/>
           </a:prstGeom>
           <a:solidFill>
-            <a:srgbClr val="6AB0F3"/>
+            <a:srgbClr val="FBBC05"/>
           </a:solidFill>
           <a:ln>
             <a:noFill/>
@@ -4133,99 +3868,13 @@
       </p:sp>
       <p:sp>
         <p:nvSpPr>
-          <p:cNvPr id="3" name="Rectangle 2"/>
-          <p:cNvSpPr/>
+          <p:cNvPr id="3" name="TextBox 2"/>
+          <p:cNvSpPr txBox="1"/>
           <p:nvPr/>
         </p:nvSpPr>
         <p:spPr>
           <a:xfrm>
-            <a:off x="4063898" y="0"/>
-            <a:ext cx="4063898" cy="45720"/>
-          </a:xfrm>
-          <a:prstGeom prst="rect">
-            <a:avLst/>
-          </a:prstGeom>
-          <a:solidFill>
-            <a:srgbClr val="BE8CFF"/>
-          </a:solidFill>
-          <a:ln>
-            <a:noFill/>
-          </a:ln>
-        </p:spPr>
-        <p:style>
-          <a:lnRef idx="1">
-            <a:schemeClr val="accent1"/>
-          </a:lnRef>
-          <a:fillRef idx="3">
-            <a:schemeClr val="accent1"/>
-          </a:fillRef>
-          <a:effectRef idx="2">
-            <a:schemeClr val="accent1"/>
-          </a:effectRef>
-          <a:fontRef idx="minor">
-            <a:schemeClr val="lt1"/>
-          </a:fontRef>
-        </p:style>
-        <p:txBody>
-          <a:bodyPr rtlCol="0" anchor="ctr"/>
-          <a:lstStyle/>
-          <a:p>
-            <a:pPr algn="ctr"/>
-          </a:p>
-        </p:txBody>
-      </p:sp>
-      <p:sp>
-        <p:nvSpPr>
-          <p:cNvPr id="4" name="Rectangle 3"/>
-          <p:cNvSpPr/>
-          <p:nvPr/>
-        </p:nvSpPr>
-        <p:spPr>
-          <a:xfrm>
-            <a:off x="8127796" y="0"/>
-            <a:ext cx="4063898" cy="45720"/>
-          </a:xfrm>
-          <a:prstGeom prst="rect">
-            <a:avLst/>
-          </a:prstGeom>
-          <a:solidFill>
-            <a:srgbClr val="00E6FF"/>
-          </a:solidFill>
-          <a:ln>
-            <a:noFill/>
-          </a:ln>
-        </p:spPr>
-        <p:style>
-          <a:lnRef idx="1">
-            <a:schemeClr val="accent1"/>
-          </a:lnRef>
-          <a:fillRef idx="3">
-            <a:schemeClr val="accent1"/>
-          </a:fillRef>
-          <a:effectRef idx="2">
-            <a:schemeClr val="accent1"/>
-          </a:effectRef>
-          <a:fontRef idx="minor">
-            <a:schemeClr val="lt1"/>
-          </a:fontRef>
-        </p:style>
-        <p:txBody>
-          <a:bodyPr rtlCol="0" anchor="ctr"/>
-          <a:lstStyle/>
-          <a:p>
-            <a:pPr algn="ctr"/>
-          </a:p>
-        </p:txBody>
-      </p:sp>
-      <p:sp>
-        <p:nvSpPr>
-          <p:cNvPr id="5" name="TextBox 4"/>
-          <p:cNvSpPr txBox="1"/>
-          <p:nvPr/>
-        </p:nvSpPr>
-        <p:spPr>
-          <a:xfrm>
-            <a:off x="914400" y="457200"/>
+            <a:off x="914400" y="548640"/>
             <a:ext cx="10362895" cy="914400"/>
           </a:xfrm>
           <a:prstGeom prst="rect">
@@ -4239,10 +3888,10 @@
           </a:bodyPr>
           <a:lstStyle/>
           <a:p>
-            <a:pPr algn="l">
-              <a:defRPr sz="4000" b="1">
-                <a:solidFill>
-                  <a:srgbClr val="F8F9FA"/>
+            <a:pPr>
+              <a:defRPr sz="4400">
+                <a:solidFill>
+                  <a:srgbClr val="1F1F1F"/>
                 </a:solidFill>
                 <a:latin typeface="Google Sans"/>
               </a:defRPr>
@@ -4255,50 +3904,7 @@
       </p:sp>
       <p:sp>
         <p:nvSpPr>
-          <p:cNvPr id="6" name="Oval 5"/>
-          <p:cNvSpPr/>
-          <p:nvPr/>
-        </p:nvSpPr>
-        <p:spPr>
-          <a:xfrm>
-            <a:off x="548640" y="777240"/>
-            <a:ext cx="137160" cy="137160"/>
-          </a:xfrm>
-          <a:prstGeom prst="ellipse">
-            <a:avLst/>
-          </a:prstGeom>
-          <a:solidFill>
-            <a:srgbClr val="6AB0F3"/>
-          </a:solidFill>
-          <a:ln>
-            <a:noFill/>
-          </a:ln>
-        </p:spPr>
-        <p:style>
-          <a:lnRef idx="1">
-            <a:schemeClr val="accent1"/>
-          </a:lnRef>
-          <a:fillRef idx="3">
-            <a:schemeClr val="accent1"/>
-          </a:fillRef>
-          <a:effectRef idx="2">
-            <a:schemeClr val="accent1"/>
-          </a:effectRef>
-          <a:fontRef idx="minor">
-            <a:schemeClr val="lt1"/>
-          </a:fontRef>
-        </p:style>
-        <p:txBody>
-          <a:bodyPr rtlCol="0" anchor="ctr"/>
-          <a:lstStyle/>
-          <a:p>
-            <a:pPr algn="ctr"/>
-          </a:p>
-        </p:txBody>
-      </p:sp>
-      <p:sp>
-        <p:nvSpPr>
-          <p:cNvPr id="7" name="Rounded Rectangle 6"/>
+          <p:cNvPr id="4" name="Rounded Rectangle 3"/>
           <p:cNvSpPr/>
           <p:nvPr/>
         </p:nvSpPr>
@@ -4311,11 +3917,11 @@
             <a:avLst/>
           </a:prstGeom>
           <a:solidFill>
-            <a:srgbClr val="141A28"/>
+            <a:srgbClr val="FFFFFF"/>
           </a:solidFill>
           <a:ln w="12700">
             <a:solidFill>
-              <a:srgbClr val="283041"/>
+              <a:srgbClr val="C4C7C5"/>
             </a:solidFill>
           </a:ln>
         </p:spPr>
@@ -4340,7 +3946,7 @@
             <a:pPr algn="ctr">
               <a:defRPr sz="2800" b="1">
                 <a:solidFill>
-                  <a:srgbClr val="6AB0F3"/>
+                  <a:srgbClr val="FBBC05"/>
                 </a:solidFill>
                 <a:latin typeface="Google Sans"/>
               </a:defRPr>
@@ -4356,9 +3962,9 @@
               </a:spcBef>
               <a:defRPr sz="2200">
                 <a:solidFill>
-                  <a:srgbClr val="A8B0B9"/>
-                </a:solidFill>
-                <a:latin typeface="Google Sans"/>
+                  <a:srgbClr val="444746"/>
+                </a:solidFill>
+                <a:latin typeface="Roboto"/>
               </a:defRPr>
             </a:pPr>
             <a:r>
@@ -4372,9 +3978,9 @@
               </a:spcBef>
               <a:defRPr sz="2200">
                 <a:solidFill>
-                  <a:srgbClr val="A8B0B9"/>
-                </a:solidFill>
-                <a:latin typeface="Google Sans"/>
+                  <a:srgbClr val="444746"/>
+                </a:solidFill>
+                <a:latin typeface="Roboto"/>
               </a:defRPr>
             </a:pPr>
             <a:r>
@@ -4388,9 +3994,9 @@
               </a:spcBef>
               <a:defRPr sz="2200">
                 <a:solidFill>
-                  <a:srgbClr val="A8B0B9"/>
-                </a:solidFill>
-                <a:latin typeface="Google Sans"/>
+                  <a:srgbClr val="444746"/>
+                </a:solidFill>
+                <a:latin typeface="Roboto"/>
               </a:defRPr>
             </a:pPr>
             <a:r>
@@ -4413,7 +4019,7 @@
     <p:bg>
       <p:bgPr>
         <a:solidFill>
-          <a:srgbClr val="0B0F19"/>
+          <a:srgbClr val="F8F9FA"/>
         </a:solidFill>
         <a:effectLst/>
       </p:bgPr>
@@ -4434,13 +4040,13 @@
         <p:spPr>
           <a:xfrm>
             <a:off x="0" y="0"/>
-            <a:ext cx="4063898" cy="45720"/>
+            <a:ext cx="12191695" cy="182880"/>
           </a:xfrm>
           <a:prstGeom prst="rect">
             <a:avLst/>
           </a:prstGeom>
           <a:solidFill>
-            <a:srgbClr val="6AB0F3"/>
+            <a:srgbClr val="4285F4"/>
           </a:solidFill>
           <a:ln>
             <a:noFill/>
@@ -4470,99 +4076,13 @@
       </p:sp>
       <p:sp>
         <p:nvSpPr>
-          <p:cNvPr id="3" name="Rectangle 2"/>
-          <p:cNvSpPr/>
+          <p:cNvPr id="3" name="TextBox 2"/>
+          <p:cNvSpPr txBox="1"/>
           <p:nvPr/>
         </p:nvSpPr>
         <p:spPr>
           <a:xfrm>
-            <a:off x="4063898" y="0"/>
-            <a:ext cx="4063898" cy="45720"/>
-          </a:xfrm>
-          <a:prstGeom prst="rect">
-            <a:avLst/>
-          </a:prstGeom>
-          <a:solidFill>
-            <a:srgbClr val="BE8CFF"/>
-          </a:solidFill>
-          <a:ln>
-            <a:noFill/>
-          </a:ln>
-        </p:spPr>
-        <p:style>
-          <a:lnRef idx="1">
-            <a:schemeClr val="accent1"/>
-          </a:lnRef>
-          <a:fillRef idx="3">
-            <a:schemeClr val="accent1"/>
-          </a:fillRef>
-          <a:effectRef idx="2">
-            <a:schemeClr val="accent1"/>
-          </a:effectRef>
-          <a:fontRef idx="minor">
-            <a:schemeClr val="lt1"/>
-          </a:fontRef>
-        </p:style>
-        <p:txBody>
-          <a:bodyPr rtlCol="0" anchor="ctr"/>
-          <a:lstStyle/>
-          <a:p>
-            <a:pPr algn="ctr"/>
-          </a:p>
-        </p:txBody>
-      </p:sp>
-      <p:sp>
-        <p:nvSpPr>
-          <p:cNvPr id="4" name="Rectangle 3"/>
-          <p:cNvSpPr/>
-          <p:nvPr/>
-        </p:nvSpPr>
-        <p:spPr>
-          <a:xfrm>
-            <a:off x="8127796" y="0"/>
-            <a:ext cx="4063898" cy="45720"/>
-          </a:xfrm>
-          <a:prstGeom prst="rect">
-            <a:avLst/>
-          </a:prstGeom>
-          <a:solidFill>
-            <a:srgbClr val="00E6FF"/>
-          </a:solidFill>
-          <a:ln>
-            <a:noFill/>
-          </a:ln>
-        </p:spPr>
-        <p:style>
-          <a:lnRef idx="1">
-            <a:schemeClr val="accent1"/>
-          </a:lnRef>
-          <a:fillRef idx="3">
-            <a:schemeClr val="accent1"/>
-          </a:fillRef>
-          <a:effectRef idx="2">
-            <a:schemeClr val="accent1"/>
-          </a:effectRef>
-          <a:fontRef idx="minor">
-            <a:schemeClr val="lt1"/>
-          </a:fontRef>
-        </p:style>
-        <p:txBody>
-          <a:bodyPr rtlCol="0" anchor="ctr"/>
-          <a:lstStyle/>
-          <a:p>
-            <a:pPr algn="ctr"/>
-          </a:p>
-        </p:txBody>
-      </p:sp>
-      <p:sp>
-        <p:nvSpPr>
-          <p:cNvPr id="5" name="TextBox 4"/>
-          <p:cNvSpPr txBox="1"/>
-          <p:nvPr/>
-        </p:nvSpPr>
-        <p:spPr>
-          <a:xfrm>
-            <a:off x="914400" y="457200"/>
+            <a:off x="914400" y="548640"/>
             <a:ext cx="10362895" cy="914400"/>
           </a:xfrm>
           <a:prstGeom prst="rect">
@@ -4576,10 +4096,10 @@
           </a:bodyPr>
           <a:lstStyle/>
           <a:p>
-            <a:pPr algn="l">
-              <a:defRPr sz="4000" b="1">
-                <a:solidFill>
-                  <a:srgbClr val="F8F9FA"/>
+            <a:pPr>
+              <a:defRPr sz="4400">
+                <a:solidFill>
+                  <a:srgbClr val="1F1F1F"/>
                 </a:solidFill>
                 <a:latin typeface="Google Sans"/>
               </a:defRPr>
@@ -4592,50 +4112,7 @@
       </p:sp>
       <p:sp>
         <p:nvSpPr>
-          <p:cNvPr id="6" name="Oval 5"/>
-          <p:cNvSpPr/>
-          <p:nvPr/>
-        </p:nvSpPr>
-        <p:spPr>
-          <a:xfrm>
-            <a:off x="548640" y="777240"/>
-            <a:ext cx="137160" cy="137160"/>
-          </a:xfrm>
-          <a:prstGeom prst="ellipse">
-            <a:avLst/>
-          </a:prstGeom>
-          <a:solidFill>
-            <a:srgbClr val="BE8CFF"/>
-          </a:solidFill>
-          <a:ln>
-            <a:noFill/>
-          </a:ln>
-        </p:spPr>
-        <p:style>
-          <a:lnRef idx="1">
-            <a:schemeClr val="accent1"/>
-          </a:lnRef>
-          <a:fillRef idx="3">
-            <a:schemeClr val="accent1"/>
-          </a:fillRef>
-          <a:effectRef idx="2">
-            <a:schemeClr val="accent1"/>
-          </a:effectRef>
-          <a:fontRef idx="minor">
-            <a:schemeClr val="lt1"/>
-          </a:fontRef>
-        </p:style>
-        <p:txBody>
-          <a:bodyPr rtlCol="0" anchor="ctr"/>
-          <a:lstStyle/>
-          <a:p>
-            <a:pPr algn="ctr"/>
-          </a:p>
-        </p:txBody>
-      </p:sp>
-      <p:sp>
-        <p:nvSpPr>
-          <p:cNvPr id="7" name="Rounded Rectangle 6"/>
+          <p:cNvPr id="4" name="Rounded Rectangle 3"/>
           <p:cNvSpPr/>
           <p:nvPr/>
         </p:nvSpPr>
@@ -4648,11 +4125,11 @@
             <a:avLst/>
           </a:prstGeom>
           <a:solidFill>
-            <a:srgbClr val="141A28"/>
+            <a:srgbClr val="FFFFFF"/>
           </a:solidFill>
           <a:ln w="12700">
             <a:solidFill>
-              <a:srgbClr val="283041"/>
+              <a:srgbClr val="C4C7C5"/>
             </a:solidFill>
           </a:ln>
         </p:spPr>
@@ -4677,7 +4154,7 @@
             <a:pPr algn="ctr">
               <a:defRPr sz="2800" b="1">
                 <a:solidFill>
-                  <a:srgbClr val="BE8CFF"/>
+                  <a:srgbClr val="4285F4"/>
                 </a:solidFill>
                 <a:latin typeface="Google Sans"/>
               </a:defRPr>
@@ -4693,9 +4170,9 @@
               </a:spcBef>
               <a:defRPr sz="2200">
                 <a:solidFill>
-                  <a:srgbClr val="A8B0B9"/>
-                </a:solidFill>
-                <a:latin typeface="Google Sans"/>
+                  <a:srgbClr val="444746"/>
+                </a:solidFill>
+                <a:latin typeface="Roboto"/>
               </a:defRPr>
             </a:pPr>
             <a:r>
@@ -4709,9 +4186,9 @@
               </a:spcBef>
               <a:defRPr sz="2200">
                 <a:solidFill>
-                  <a:srgbClr val="A8B0B9"/>
-                </a:solidFill>
-                <a:latin typeface="Google Sans"/>
+                  <a:srgbClr val="444746"/>
+                </a:solidFill>
+                <a:latin typeface="Roboto"/>
               </a:defRPr>
             </a:pPr>
             <a:r>
@@ -4725,9 +4202,9 @@
               </a:spcBef>
               <a:defRPr sz="2200">
                 <a:solidFill>
-                  <a:srgbClr val="A8B0B9"/>
-                </a:solidFill>
-                <a:latin typeface="Google Sans"/>
+                  <a:srgbClr val="444746"/>
+                </a:solidFill>
+                <a:latin typeface="Roboto"/>
               </a:defRPr>
             </a:pPr>
             <a:r>
@@ -4741,9 +4218,9 @@
               </a:spcBef>
               <a:defRPr sz="2200">
                 <a:solidFill>
-                  <a:srgbClr val="A8B0B9"/>
-                </a:solidFill>
-                <a:latin typeface="Google Sans"/>
+                  <a:srgbClr val="444746"/>
+                </a:solidFill>
+                <a:latin typeface="Roboto"/>
               </a:defRPr>
             </a:pPr>
             <a:r>
@@ -4757,9 +4234,9 @@
               </a:spcBef>
               <a:defRPr sz="2200">
                 <a:solidFill>
-                  <a:srgbClr val="A8B0B9"/>
-                </a:solidFill>
-                <a:latin typeface="Google Sans"/>
+                  <a:srgbClr val="444746"/>
+                </a:solidFill>
+                <a:latin typeface="Roboto"/>
               </a:defRPr>
             </a:pPr>
             <a:r>
@@ -4782,7 +4259,7 @@
     <p:bg>
       <p:bgPr>
         <a:solidFill>
-          <a:srgbClr val="0B0F19"/>
+          <a:srgbClr val="F8F9FA"/>
         </a:solidFill>
         <a:effectLst/>
       </p:bgPr>
@@ -4803,13 +4280,13 @@
         <p:spPr>
           <a:xfrm>
             <a:off x="0" y="0"/>
-            <a:ext cx="4063898" cy="45720"/>
+            <a:ext cx="12191695" cy="182880"/>
           </a:xfrm>
           <a:prstGeom prst="rect">
             <a:avLst/>
           </a:prstGeom>
           <a:solidFill>
-            <a:srgbClr val="6AB0F3"/>
+            <a:srgbClr val="EA4335"/>
           </a:solidFill>
           <a:ln>
             <a:noFill/>
@@ -4839,99 +4316,13 @@
       </p:sp>
       <p:sp>
         <p:nvSpPr>
-          <p:cNvPr id="3" name="Rectangle 2"/>
-          <p:cNvSpPr/>
+          <p:cNvPr id="3" name="TextBox 2"/>
+          <p:cNvSpPr txBox="1"/>
           <p:nvPr/>
         </p:nvSpPr>
         <p:spPr>
           <a:xfrm>
-            <a:off x="4063898" y="0"/>
-            <a:ext cx="4063898" cy="45720"/>
-          </a:xfrm>
-          <a:prstGeom prst="rect">
-            <a:avLst/>
-          </a:prstGeom>
-          <a:solidFill>
-            <a:srgbClr val="BE8CFF"/>
-          </a:solidFill>
-          <a:ln>
-            <a:noFill/>
-          </a:ln>
-        </p:spPr>
-        <p:style>
-          <a:lnRef idx="1">
-            <a:schemeClr val="accent1"/>
-          </a:lnRef>
-          <a:fillRef idx="3">
-            <a:schemeClr val="accent1"/>
-          </a:fillRef>
-          <a:effectRef idx="2">
-            <a:schemeClr val="accent1"/>
-          </a:effectRef>
-          <a:fontRef idx="minor">
-            <a:schemeClr val="lt1"/>
-          </a:fontRef>
-        </p:style>
-        <p:txBody>
-          <a:bodyPr rtlCol="0" anchor="ctr"/>
-          <a:lstStyle/>
-          <a:p>
-            <a:pPr algn="ctr"/>
-          </a:p>
-        </p:txBody>
-      </p:sp>
-      <p:sp>
-        <p:nvSpPr>
-          <p:cNvPr id="4" name="Rectangle 3"/>
-          <p:cNvSpPr/>
-          <p:nvPr/>
-        </p:nvSpPr>
-        <p:spPr>
-          <a:xfrm>
-            <a:off x="8127796" y="0"/>
-            <a:ext cx="4063898" cy="45720"/>
-          </a:xfrm>
-          <a:prstGeom prst="rect">
-            <a:avLst/>
-          </a:prstGeom>
-          <a:solidFill>
-            <a:srgbClr val="00E6FF"/>
-          </a:solidFill>
-          <a:ln>
-            <a:noFill/>
-          </a:ln>
-        </p:spPr>
-        <p:style>
-          <a:lnRef idx="1">
-            <a:schemeClr val="accent1"/>
-          </a:lnRef>
-          <a:fillRef idx="3">
-            <a:schemeClr val="accent1"/>
-          </a:fillRef>
-          <a:effectRef idx="2">
-            <a:schemeClr val="accent1"/>
-          </a:effectRef>
-          <a:fontRef idx="minor">
-            <a:schemeClr val="lt1"/>
-          </a:fontRef>
-        </p:style>
-        <p:txBody>
-          <a:bodyPr rtlCol="0" anchor="ctr"/>
-          <a:lstStyle/>
-          <a:p>
-            <a:pPr algn="ctr"/>
-          </a:p>
-        </p:txBody>
-      </p:sp>
-      <p:sp>
-        <p:nvSpPr>
-          <p:cNvPr id="5" name="TextBox 4"/>
-          <p:cNvSpPr txBox="1"/>
-          <p:nvPr/>
-        </p:nvSpPr>
-        <p:spPr>
-          <a:xfrm>
-            <a:off x="914400" y="457200"/>
+            <a:off x="914400" y="548640"/>
             <a:ext cx="10362895" cy="914400"/>
           </a:xfrm>
           <a:prstGeom prst="rect">
@@ -4945,10 +4336,10 @@
           </a:bodyPr>
           <a:lstStyle/>
           <a:p>
-            <a:pPr algn="l">
-              <a:defRPr sz="4000" b="1">
-                <a:solidFill>
-                  <a:srgbClr val="F8F9FA"/>
+            <a:pPr>
+              <a:defRPr sz="4400">
+                <a:solidFill>
+                  <a:srgbClr val="1F1F1F"/>
                 </a:solidFill>
                 <a:latin typeface="Google Sans"/>
               </a:defRPr>
@@ -4961,50 +4352,7 @@
       </p:sp>
       <p:sp>
         <p:nvSpPr>
-          <p:cNvPr id="6" name="Oval 5"/>
-          <p:cNvSpPr/>
-          <p:nvPr/>
-        </p:nvSpPr>
-        <p:spPr>
-          <a:xfrm>
-            <a:off x="548640" y="777240"/>
-            <a:ext cx="137160" cy="137160"/>
-          </a:xfrm>
-          <a:prstGeom prst="ellipse">
-            <a:avLst/>
-          </a:prstGeom>
-          <a:solidFill>
-            <a:srgbClr val="FF8AB3"/>
-          </a:solidFill>
-          <a:ln>
-            <a:noFill/>
-          </a:ln>
-        </p:spPr>
-        <p:style>
-          <a:lnRef idx="1">
-            <a:schemeClr val="accent1"/>
-          </a:lnRef>
-          <a:fillRef idx="3">
-            <a:schemeClr val="accent1"/>
-          </a:fillRef>
-          <a:effectRef idx="2">
-            <a:schemeClr val="accent1"/>
-          </a:effectRef>
-          <a:fontRef idx="minor">
-            <a:schemeClr val="lt1"/>
-          </a:fontRef>
-        </p:style>
-        <p:txBody>
-          <a:bodyPr rtlCol="0" anchor="ctr"/>
-          <a:lstStyle/>
-          <a:p>
-            <a:pPr algn="ctr"/>
-          </a:p>
-        </p:txBody>
-      </p:sp>
-      <p:sp>
-        <p:nvSpPr>
-          <p:cNvPr id="7" name="Rounded Rectangle 6"/>
+          <p:cNvPr id="4" name="Rounded Rectangle 3"/>
           <p:cNvSpPr/>
           <p:nvPr/>
         </p:nvSpPr>
@@ -5017,11 +4365,11 @@
             <a:avLst/>
           </a:prstGeom>
           <a:solidFill>
-            <a:srgbClr val="141A28"/>
+            <a:srgbClr val="FFFFFF"/>
           </a:solidFill>
           <a:ln w="12700">
             <a:solidFill>
-              <a:srgbClr val="283041"/>
+              <a:srgbClr val="C4C7C5"/>
             </a:solidFill>
           </a:ln>
         </p:spPr>
@@ -5046,7 +4394,7 @@
             <a:pPr algn="ctr">
               <a:defRPr sz="2800" b="1">
                 <a:solidFill>
-                  <a:srgbClr val="FF8AB3"/>
+                  <a:srgbClr val="EA4335"/>
                 </a:solidFill>
                 <a:latin typeface="Google Sans"/>
               </a:defRPr>
@@ -5062,9 +4410,9 @@
               </a:spcBef>
               <a:defRPr sz="2200">
                 <a:solidFill>
-                  <a:srgbClr val="A8B0B9"/>
-                </a:solidFill>
-                <a:latin typeface="Google Sans"/>
+                  <a:srgbClr val="444746"/>
+                </a:solidFill>
+                <a:latin typeface="Roboto"/>
               </a:defRPr>
             </a:pPr>
             <a:r>
@@ -5078,9 +4426,9 @@
               </a:spcBef>
               <a:defRPr sz="2200">
                 <a:solidFill>
-                  <a:srgbClr val="A8B0B9"/>
-                </a:solidFill>
-                <a:latin typeface="Google Sans"/>
+                  <a:srgbClr val="444746"/>
+                </a:solidFill>
+                <a:latin typeface="Roboto"/>
               </a:defRPr>
             </a:pPr>
             <a:r>
@@ -5094,9 +4442,9 @@
               </a:spcBef>
               <a:defRPr sz="2200">
                 <a:solidFill>
-                  <a:srgbClr val="A8B0B9"/>
-                </a:solidFill>
-                <a:latin typeface="Google Sans"/>
+                  <a:srgbClr val="444746"/>
+                </a:solidFill>
+                <a:latin typeface="Roboto"/>
               </a:defRPr>
             </a:pPr>
             <a:r>
@@ -5119,7 +4467,7 @@
     <p:bg>
       <p:bgPr>
         <a:solidFill>
-          <a:srgbClr val="0B0F19"/>
+          <a:srgbClr val="F8F9FA"/>
         </a:solidFill>
         <a:effectLst/>
       </p:bgPr>
@@ -5140,13 +4488,13 @@
         <p:spPr>
           <a:xfrm>
             <a:off x="0" y="0"/>
-            <a:ext cx="4063898" cy="45720"/>
+            <a:ext cx="12191695" cy="182880"/>
           </a:xfrm>
           <a:prstGeom prst="rect">
             <a:avLst/>
           </a:prstGeom>
           <a:solidFill>
-            <a:srgbClr val="6AB0F3"/>
+            <a:srgbClr val="34A853"/>
           </a:solidFill>
           <a:ln>
             <a:noFill/>
@@ -5176,99 +4524,13 @@
       </p:sp>
       <p:sp>
         <p:nvSpPr>
-          <p:cNvPr id="3" name="Rectangle 2"/>
-          <p:cNvSpPr/>
+          <p:cNvPr id="3" name="TextBox 2"/>
+          <p:cNvSpPr txBox="1"/>
           <p:nvPr/>
         </p:nvSpPr>
         <p:spPr>
           <a:xfrm>
-            <a:off x="4063898" y="0"/>
-            <a:ext cx="4063898" cy="45720"/>
-          </a:xfrm>
-          <a:prstGeom prst="rect">
-            <a:avLst/>
-          </a:prstGeom>
-          <a:solidFill>
-            <a:srgbClr val="BE8CFF"/>
-          </a:solidFill>
-          <a:ln>
-            <a:noFill/>
-          </a:ln>
-        </p:spPr>
-        <p:style>
-          <a:lnRef idx="1">
-            <a:schemeClr val="accent1"/>
-          </a:lnRef>
-          <a:fillRef idx="3">
-            <a:schemeClr val="accent1"/>
-          </a:fillRef>
-          <a:effectRef idx="2">
-            <a:schemeClr val="accent1"/>
-          </a:effectRef>
-          <a:fontRef idx="minor">
-            <a:schemeClr val="lt1"/>
-          </a:fontRef>
-        </p:style>
-        <p:txBody>
-          <a:bodyPr rtlCol="0" anchor="ctr"/>
-          <a:lstStyle/>
-          <a:p>
-            <a:pPr algn="ctr"/>
-          </a:p>
-        </p:txBody>
-      </p:sp>
-      <p:sp>
-        <p:nvSpPr>
-          <p:cNvPr id="4" name="Rectangle 3"/>
-          <p:cNvSpPr/>
-          <p:nvPr/>
-        </p:nvSpPr>
-        <p:spPr>
-          <a:xfrm>
-            <a:off x="8127796" y="0"/>
-            <a:ext cx="4063898" cy="45720"/>
-          </a:xfrm>
-          <a:prstGeom prst="rect">
-            <a:avLst/>
-          </a:prstGeom>
-          <a:solidFill>
-            <a:srgbClr val="00E6FF"/>
-          </a:solidFill>
-          <a:ln>
-            <a:noFill/>
-          </a:ln>
-        </p:spPr>
-        <p:style>
-          <a:lnRef idx="1">
-            <a:schemeClr val="accent1"/>
-          </a:lnRef>
-          <a:fillRef idx="3">
-            <a:schemeClr val="accent1"/>
-          </a:fillRef>
-          <a:effectRef idx="2">
-            <a:schemeClr val="accent1"/>
-          </a:effectRef>
-          <a:fontRef idx="minor">
-            <a:schemeClr val="lt1"/>
-          </a:fontRef>
-        </p:style>
-        <p:txBody>
-          <a:bodyPr rtlCol="0" anchor="ctr"/>
-          <a:lstStyle/>
-          <a:p>
-            <a:pPr algn="ctr"/>
-          </a:p>
-        </p:txBody>
-      </p:sp>
-      <p:sp>
-        <p:nvSpPr>
-          <p:cNvPr id="5" name="TextBox 4"/>
-          <p:cNvSpPr txBox="1"/>
-          <p:nvPr/>
-        </p:nvSpPr>
-        <p:spPr>
-          <a:xfrm>
-            <a:off x="914400" y="457200"/>
+            <a:off x="914400" y="548640"/>
             <a:ext cx="10362895" cy="914400"/>
           </a:xfrm>
           <a:prstGeom prst="rect">
@@ -5282,10 +4544,10 @@
           </a:bodyPr>
           <a:lstStyle/>
           <a:p>
-            <a:pPr algn="l">
-              <a:defRPr sz="4000" b="1">
-                <a:solidFill>
-                  <a:srgbClr val="F8F9FA"/>
+            <a:pPr>
+              <a:defRPr sz="4400">
+                <a:solidFill>
+                  <a:srgbClr val="1F1F1F"/>
                 </a:solidFill>
                 <a:latin typeface="Google Sans"/>
               </a:defRPr>
@@ -5298,50 +4560,7 @@
       </p:sp>
       <p:sp>
         <p:nvSpPr>
-          <p:cNvPr id="6" name="Oval 5"/>
-          <p:cNvSpPr/>
-          <p:nvPr/>
-        </p:nvSpPr>
-        <p:spPr>
-          <a:xfrm>
-            <a:off x="548640" y="777240"/>
-            <a:ext cx="137160" cy="137160"/>
-          </a:xfrm>
-          <a:prstGeom prst="ellipse">
-            <a:avLst/>
-          </a:prstGeom>
-          <a:solidFill>
-            <a:srgbClr val="00E6FF"/>
-          </a:solidFill>
-          <a:ln>
-            <a:noFill/>
-          </a:ln>
-        </p:spPr>
-        <p:style>
-          <a:lnRef idx="1">
-            <a:schemeClr val="accent1"/>
-          </a:lnRef>
-          <a:fillRef idx="3">
-            <a:schemeClr val="accent1"/>
-          </a:fillRef>
-          <a:effectRef idx="2">
-            <a:schemeClr val="accent1"/>
-          </a:effectRef>
-          <a:fontRef idx="minor">
-            <a:schemeClr val="lt1"/>
-          </a:fontRef>
-        </p:style>
-        <p:txBody>
-          <a:bodyPr rtlCol="0" anchor="ctr"/>
-          <a:lstStyle/>
-          <a:p>
-            <a:pPr algn="ctr"/>
-          </a:p>
-        </p:txBody>
-      </p:sp>
-      <p:sp>
-        <p:nvSpPr>
-          <p:cNvPr id="7" name="Rounded Rectangle 6"/>
+          <p:cNvPr id="4" name="Rounded Rectangle 3"/>
           <p:cNvSpPr/>
           <p:nvPr/>
         </p:nvSpPr>
@@ -5354,11 +4573,11 @@
             <a:avLst/>
           </a:prstGeom>
           <a:solidFill>
-            <a:srgbClr val="141A28"/>
+            <a:srgbClr val="FFFFFF"/>
           </a:solidFill>
           <a:ln w="12700">
             <a:solidFill>
-              <a:srgbClr val="283041"/>
+              <a:srgbClr val="C4C7C5"/>
             </a:solidFill>
           </a:ln>
         </p:spPr>
@@ -5383,7 +4602,7 @@
             <a:pPr algn="ctr">
               <a:defRPr sz="2800" b="1">
                 <a:solidFill>
-                  <a:srgbClr val="00E6FF"/>
+                  <a:srgbClr val="34A853"/>
                 </a:solidFill>
                 <a:latin typeface="Google Sans"/>
               </a:defRPr>
@@ -5399,9 +4618,9 @@
               </a:spcBef>
               <a:defRPr sz="2200">
                 <a:solidFill>
-                  <a:srgbClr val="A8B0B9"/>
-                </a:solidFill>
-                <a:latin typeface="Google Sans"/>
+                  <a:srgbClr val="444746"/>
+                </a:solidFill>
+                <a:latin typeface="Roboto"/>
               </a:defRPr>
             </a:pPr>
             <a:r>
@@ -5415,9 +4634,9 @@
               </a:spcBef>
               <a:defRPr sz="2200">
                 <a:solidFill>
-                  <a:srgbClr val="A8B0B9"/>
-                </a:solidFill>
-                <a:latin typeface="Google Sans"/>
+                  <a:srgbClr val="444746"/>
+                </a:solidFill>
+                <a:latin typeface="Roboto"/>
               </a:defRPr>
             </a:pPr>
             <a:r>
@@ -5431,9 +4650,9 @@
               </a:spcBef>
               <a:defRPr sz="2200">
                 <a:solidFill>
-                  <a:srgbClr val="A8B0B9"/>
-                </a:solidFill>
-                <a:latin typeface="Google Sans"/>
+                  <a:srgbClr val="444746"/>
+                </a:solidFill>
+                <a:latin typeface="Roboto"/>
               </a:defRPr>
             </a:pPr>
             <a:r>
@@ -5447,9 +4666,9 @@
               </a:spcBef>
               <a:defRPr sz="2200">
                 <a:solidFill>
-                  <a:srgbClr val="A8B0B9"/>
-                </a:solidFill>
-                <a:latin typeface="Google Sans"/>
+                  <a:srgbClr val="444746"/>
+                </a:solidFill>
+                <a:latin typeface="Roboto"/>
               </a:defRPr>
             </a:pPr>
             <a:r>
@@ -5472,7 +4691,7 @@
     <p:bg>
       <p:bgPr>
         <a:solidFill>
-          <a:srgbClr val="0B0F19"/>
+          <a:srgbClr val="F8F9FA"/>
         </a:solidFill>
         <a:effectLst/>
       </p:bgPr>
@@ -5493,13 +4712,13 @@
         <p:spPr>
           <a:xfrm>
             <a:off x="0" y="0"/>
-            <a:ext cx="4063898" cy="45720"/>
+            <a:ext cx="12191695" cy="182880"/>
           </a:xfrm>
           <a:prstGeom prst="rect">
             <a:avLst/>
           </a:prstGeom>
           <a:solidFill>
-            <a:srgbClr val="6AB0F3"/>
+            <a:srgbClr val="FBBC05"/>
           </a:solidFill>
           <a:ln>
             <a:noFill/>
@@ -5529,99 +4748,13 @@
       </p:sp>
       <p:sp>
         <p:nvSpPr>
-          <p:cNvPr id="3" name="Rectangle 2"/>
-          <p:cNvSpPr/>
+          <p:cNvPr id="3" name="TextBox 2"/>
+          <p:cNvSpPr txBox="1"/>
           <p:nvPr/>
         </p:nvSpPr>
         <p:spPr>
           <a:xfrm>
-            <a:off x="4063898" y="0"/>
-            <a:ext cx="4063898" cy="45720"/>
-          </a:xfrm>
-          <a:prstGeom prst="rect">
-            <a:avLst/>
-          </a:prstGeom>
-          <a:solidFill>
-            <a:srgbClr val="BE8CFF"/>
-          </a:solidFill>
-          <a:ln>
-            <a:noFill/>
-          </a:ln>
-        </p:spPr>
-        <p:style>
-          <a:lnRef idx="1">
-            <a:schemeClr val="accent1"/>
-          </a:lnRef>
-          <a:fillRef idx="3">
-            <a:schemeClr val="accent1"/>
-          </a:fillRef>
-          <a:effectRef idx="2">
-            <a:schemeClr val="accent1"/>
-          </a:effectRef>
-          <a:fontRef idx="minor">
-            <a:schemeClr val="lt1"/>
-          </a:fontRef>
-        </p:style>
-        <p:txBody>
-          <a:bodyPr rtlCol="0" anchor="ctr"/>
-          <a:lstStyle/>
-          <a:p>
-            <a:pPr algn="ctr"/>
-          </a:p>
-        </p:txBody>
-      </p:sp>
-      <p:sp>
-        <p:nvSpPr>
-          <p:cNvPr id="4" name="Rectangle 3"/>
-          <p:cNvSpPr/>
-          <p:nvPr/>
-        </p:nvSpPr>
-        <p:spPr>
-          <a:xfrm>
-            <a:off x="8127796" y="0"/>
-            <a:ext cx="4063898" cy="45720"/>
-          </a:xfrm>
-          <a:prstGeom prst="rect">
-            <a:avLst/>
-          </a:prstGeom>
-          <a:solidFill>
-            <a:srgbClr val="00E6FF"/>
-          </a:solidFill>
-          <a:ln>
-            <a:noFill/>
-          </a:ln>
-        </p:spPr>
-        <p:style>
-          <a:lnRef idx="1">
-            <a:schemeClr val="accent1"/>
-          </a:lnRef>
-          <a:fillRef idx="3">
-            <a:schemeClr val="accent1"/>
-          </a:fillRef>
-          <a:effectRef idx="2">
-            <a:schemeClr val="accent1"/>
-          </a:effectRef>
-          <a:fontRef idx="minor">
-            <a:schemeClr val="lt1"/>
-          </a:fontRef>
-        </p:style>
-        <p:txBody>
-          <a:bodyPr rtlCol="0" anchor="ctr"/>
-          <a:lstStyle/>
-          <a:p>
-            <a:pPr algn="ctr"/>
-          </a:p>
-        </p:txBody>
-      </p:sp>
-      <p:sp>
-        <p:nvSpPr>
-          <p:cNvPr id="5" name="TextBox 4"/>
-          <p:cNvSpPr txBox="1"/>
-          <p:nvPr/>
-        </p:nvSpPr>
-        <p:spPr>
-          <a:xfrm>
-            <a:off x="914400" y="457200"/>
+            <a:off x="914400" y="548640"/>
             <a:ext cx="10362895" cy="914400"/>
           </a:xfrm>
           <a:prstGeom prst="rect">
@@ -5635,10 +4768,10 @@
           </a:bodyPr>
           <a:lstStyle/>
           <a:p>
-            <a:pPr algn="l">
-              <a:defRPr sz="4000" b="1">
-                <a:solidFill>
-                  <a:srgbClr val="F8F9FA"/>
+            <a:pPr>
+              <a:defRPr sz="4400">
+                <a:solidFill>
+                  <a:srgbClr val="1F1F1F"/>
                 </a:solidFill>
                 <a:latin typeface="Google Sans"/>
               </a:defRPr>
@@ -5651,50 +4784,7 @@
       </p:sp>
       <p:sp>
         <p:nvSpPr>
-          <p:cNvPr id="6" name="Oval 5"/>
-          <p:cNvSpPr/>
-          <p:nvPr/>
-        </p:nvSpPr>
-        <p:spPr>
-          <a:xfrm>
-            <a:off x="548640" y="777240"/>
-            <a:ext cx="137160" cy="137160"/>
-          </a:xfrm>
-          <a:prstGeom prst="ellipse">
-            <a:avLst/>
-          </a:prstGeom>
-          <a:solidFill>
-            <a:srgbClr val="6AB0F3"/>
-          </a:solidFill>
-          <a:ln>
-            <a:noFill/>
-          </a:ln>
-        </p:spPr>
-        <p:style>
-          <a:lnRef idx="1">
-            <a:schemeClr val="accent1"/>
-          </a:lnRef>
-          <a:fillRef idx="3">
-            <a:schemeClr val="accent1"/>
-          </a:fillRef>
-          <a:effectRef idx="2">
-            <a:schemeClr val="accent1"/>
-          </a:effectRef>
-          <a:fontRef idx="minor">
-            <a:schemeClr val="lt1"/>
-          </a:fontRef>
-        </p:style>
-        <p:txBody>
-          <a:bodyPr rtlCol="0" anchor="ctr"/>
-          <a:lstStyle/>
-          <a:p>
-            <a:pPr algn="ctr"/>
-          </a:p>
-        </p:txBody>
-      </p:sp>
-      <p:sp>
-        <p:nvSpPr>
-          <p:cNvPr id="7" name="Rounded Rectangle 6"/>
+          <p:cNvPr id="4" name="Rounded Rectangle 3"/>
           <p:cNvSpPr/>
           <p:nvPr/>
         </p:nvSpPr>
@@ -5707,11 +4797,11 @@
             <a:avLst/>
           </a:prstGeom>
           <a:solidFill>
-            <a:srgbClr val="141A28"/>
+            <a:srgbClr val="FFFFFF"/>
           </a:solidFill>
           <a:ln w="12700">
             <a:solidFill>
-              <a:srgbClr val="283041"/>
+              <a:srgbClr val="C4C7C5"/>
             </a:solidFill>
           </a:ln>
         </p:spPr>
@@ -5736,7 +4826,7 @@
             <a:pPr algn="ctr">
               <a:defRPr sz="2800" b="1">
                 <a:solidFill>
-                  <a:srgbClr val="6AB0F3"/>
+                  <a:srgbClr val="FBBC05"/>
                 </a:solidFill>
                 <a:latin typeface="Google Sans"/>
               </a:defRPr>
@@ -5752,9 +4842,9 @@
               </a:spcBef>
               <a:defRPr sz="2200">
                 <a:solidFill>
-                  <a:srgbClr val="A8B0B9"/>
-                </a:solidFill>
-                <a:latin typeface="Google Sans"/>
+                  <a:srgbClr val="444746"/>
+                </a:solidFill>
+                <a:latin typeface="Roboto"/>
               </a:defRPr>
             </a:pPr>
             <a:r>
@@ -5768,9 +4858,9 @@
               </a:spcBef>
               <a:defRPr sz="2200">
                 <a:solidFill>
-                  <a:srgbClr val="A8B0B9"/>
-                </a:solidFill>
-                <a:latin typeface="Google Sans"/>
+                  <a:srgbClr val="444746"/>
+                </a:solidFill>
+                <a:latin typeface="Roboto"/>
               </a:defRPr>
             </a:pPr>
             <a:r>
@@ -5784,9 +4874,9 @@
               </a:spcBef>
               <a:defRPr sz="2200">
                 <a:solidFill>
-                  <a:srgbClr val="A8B0B9"/>
-                </a:solidFill>
-                <a:latin typeface="Google Sans"/>
+                  <a:srgbClr val="444746"/>
+                </a:solidFill>
+                <a:latin typeface="Roboto"/>
               </a:defRPr>
             </a:pPr>
             <a:r>
@@ -5800,9 +4890,9 @@
               </a:spcBef>
               <a:defRPr sz="2200">
                 <a:solidFill>
-                  <a:srgbClr val="A8B0B9"/>
-                </a:solidFill>
-                <a:latin typeface="Google Sans"/>
+                  <a:srgbClr val="444746"/>
+                </a:solidFill>
+                <a:latin typeface="Roboto"/>
               </a:defRPr>
             </a:pPr>
             <a:r>
@@ -5816,9 +4906,9 @@
               </a:spcBef>
               <a:defRPr sz="2200">
                 <a:solidFill>
-                  <a:srgbClr val="A8B0B9"/>
-                </a:solidFill>
-                <a:latin typeface="Google Sans"/>
+                  <a:srgbClr val="444746"/>
+                </a:solidFill>
+                <a:latin typeface="Roboto"/>
               </a:defRPr>
             </a:pPr>
             <a:r>
@@ -5841,7 +4931,7 @@
     <p:bg>
       <p:bgPr>
         <a:solidFill>
-          <a:srgbClr val="0B0F19"/>
+          <a:srgbClr val="F8F9FA"/>
         </a:solidFill>
         <a:effectLst/>
       </p:bgPr>
@@ -5862,13 +4952,13 @@
         <p:spPr>
           <a:xfrm>
             <a:off x="0" y="0"/>
-            <a:ext cx="4063898" cy="45720"/>
+            <a:ext cx="12191695" cy="182880"/>
           </a:xfrm>
           <a:prstGeom prst="rect">
             <a:avLst/>
           </a:prstGeom>
           <a:solidFill>
-            <a:srgbClr val="6AB0F3"/>
+            <a:srgbClr val="4285F4"/>
           </a:solidFill>
           <a:ln>
             <a:noFill/>
@@ -5898,99 +4988,13 @@
       </p:sp>
       <p:sp>
         <p:nvSpPr>
-          <p:cNvPr id="3" name="Rectangle 2"/>
-          <p:cNvSpPr/>
+          <p:cNvPr id="3" name="TextBox 2"/>
+          <p:cNvSpPr txBox="1"/>
           <p:nvPr/>
         </p:nvSpPr>
         <p:spPr>
           <a:xfrm>
-            <a:off x="4063898" y="0"/>
-            <a:ext cx="4063898" cy="45720"/>
-          </a:xfrm>
-          <a:prstGeom prst="rect">
-            <a:avLst/>
-          </a:prstGeom>
-          <a:solidFill>
-            <a:srgbClr val="BE8CFF"/>
-          </a:solidFill>
-          <a:ln>
-            <a:noFill/>
-          </a:ln>
-        </p:spPr>
-        <p:style>
-          <a:lnRef idx="1">
-            <a:schemeClr val="accent1"/>
-          </a:lnRef>
-          <a:fillRef idx="3">
-            <a:schemeClr val="accent1"/>
-          </a:fillRef>
-          <a:effectRef idx="2">
-            <a:schemeClr val="accent1"/>
-          </a:effectRef>
-          <a:fontRef idx="minor">
-            <a:schemeClr val="lt1"/>
-          </a:fontRef>
-        </p:style>
-        <p:txBody>
-          <a:bodyPr rtlCol="0" anchor="ctr"/>
-          <a:lstStyle/>
-          <a:p>
-            <a:pPr algn="ctr"/>
-          </a:p>
-        </p:txBody>
-      </p:sp>
-      <p:sp>
-        <p:nvSpPr>
-          <p:cNvPr id="4" name="Rectangle 3"/>
-          <p:cNvSpPr/>
-          <p:nvPr/>
-        </p:nvSpPr>
-        <p:spPr>
-          <a:xfrm>
-            <a:off x="8127796" y="0"/>
-            <a:ext cx="4063898" cy="45720"/>
-          </a:xfrm>
-          <a:prstGeom prst="rect">
-            <a:avLst/>
-          </a:prstGeom>
-          <a:solidFill>
-            <a:srgbClr val="00E6FF"/>
-          </a:solidFill>
-          <a:ln>
-            <a:noFill/>
-          </a:ln>
-        </p:spPr>
-        <p:style>
-          <a:lnRef idx="1">
-            <a:schemeClr val="accent1"/>
-          </a:lnRef>
-          <a:fillRef idx="3">
-            <a:schemeClr val="accent1"/>
-          </a:fillRef>
-          <a:effectRef idx="2">
-            <a:schemeClr val="accent1"/>
-          </a:effectRef>
-          <a:fontRef idx="minor">
-            <a:schemeClr val="lt1"/>
-          </a:fontRef>
-        </p:style>
-        <p:txBody>
-          <a:bodyPr rtlCol="0" anchor="ctr"/>
-          <a:lstStyle/>
-          <a:p>
-            <a:pPr algn="ctr"/>
-          </a:p>
-        </p:txBody>
-      </p:sp>
-      <p:sp>
-        <p:nvSpPr>
-          <p:cNvPr id="5" name="TextBox 4"/>
-          <p:cNvSpPr txBox="1"/>
-          <p:nvPr/>
-        </p:nvSpPr>
-        <p:spPr>
-          <a:xfrm>
-            <a:off x="914400" y="457200"/>
+            <a:off x="914400" y="548640"/>
             <a:ext cx="10362895" cy="914400"/>
           </a:xfrm>
           <a:prstGeom prst="rect">
@@ -6004,10 +5008,10 @@
           </a:bodyPr>
           <a:lstStyle/>
           <a:p>
-            <a:pPr algn="l">
-              <a:defRPr sz="4000" b="1">
-                <a:solidFill>
-                  <a:srgbClr val="F8F9FA"/>
+            <a:pPr>
+              <a:defRPr sz="4400">
+                <a:solidFill>
+                  <a:srgbClr val="1F1F1F"/>
                 </a:solidFill>
                 <a:latin typeface="Google Sans"/>
               </a:defRPr>
@@ -6020,50 +5024,7 @@
       </p:sp>
       <p:sp>
         <p:nvSpPr>
-          <p:cNvPr id="6" name="Oval 5"/>
-          <p:cNvSpPr/>
-          <p:nvPr/>
-        </p:nvSpPr>
-        <p:spPr>
-          <a:xfrm>
-            <a:off x="548640" y="777240"/>
-            <a:ext cx="137160" cy="137160"/>
-          </a:xfrm>
-          <a:prstGeom prst="ellipse">
-            <a:avLst/>
-          </a:prstGeom>
-          <a:solidFill>
-            <a:srgbClr val="BE8CFF"/>
-          </a:solidFill>
-          <a:ln>
-            <a:noFill/>
-          </a:ln>
-        </p:spPr>
-        <p:style>
-          <a:lnRef idx="1">
-            <a:schemeClr val="accent1"/>
-          </a:lnRef>
-          <a:fillRef idx="3">
-            <a:schemeClr val="accent1"/>
-          </a:fillRef>
-          <a:effectRef idx="2">
-            <a:schemeClr val="accent1"/>
-          </a:effectRef>
-          <a:fontRef idx="minor">
-            <a:schemeClr val="lt1"/>
-          </a:fontRef>
-        </p:style>
-        <p:txBody>
-          <a:bodyPr rtlCol="0" anchor="ctr"/>
-          <a:lstStyle/>
-          <a:p>
-            <a:pPr algn="ctr"/>
-          </a:p>
-        </p:txBody>
-      </p:sp>
-      <p:sp>
-        <p:nvSpPr>
-          <p:cNvPr id="7" name="Rounded Rectangle 6"/>
+          <p:cNvPr id="4" name="Rounded Rectangle 3"/>
           <p:cNvSpPr/>
           <p:nvPr/>
         </p:nvSpPr>
@@ -6076,11 +5037,11 @@
             <a:avLst/>
           </a:prstGeom>
           <a:solidFill>
-            <a:srgbClr val="141A28"/>
+            <a:srgbClr val="FFFFFF"/>
           </a:solidFill>
           <a:ln w="12700">
             <a:solidFill>
-              <a:srgbClr val="283041"/>
+              <a:srgbClr val="C4C7C5"/>
             </a:solidFill>
           </a:ln>
         </p:spPr>
@@ -6105,7 +5066,7 @@
             <a:pPr algn="ctr">
               <a:defRPr sz="2800" b="1">
                 <a:solidFill>
-                  <a:srgbClr val="BE8CFF"/>
+                  <a:srgbClr val="4285F4"/>
                 </a:solidFill>
                 <a:latin typeface="Google Sans"/>
               </a:defRPr>
@@ -6121,9 +5082,9 @@
               </a:spcBef>
               <a:defRPr sz="2200">
                 <a:solidFill>
-                  <a:srgbClr val="A8B0B9"/>
-                </a:solidFill>
-                <a:latin typeface="Google Sans"/>
+                  <a:srgbClr val="444746"/>
+                </a:solidFill>
+                <a:latin typeface="Roboto"/>
               </a:defRPr>
             </a:pPr>
             <a:r>
@@ -6137,9 +5098,9 @@
               </a:spcBef>
               <a:defRPr sz="2200">
                 <a:solidFill>
-                  <a:srgbClr val="A8B0B9"/>
-                </a:solidFill>
-                <a:latin typeface="Google Sans"/>
+                  <a:srgbClr val="444746"/>
+                </a:solidFill>
+                <a:latin typeface="Roboto"/>
               </a:defRPr>
             </a:pPr>
             <a:r>
@@ -6153,9 +5114,9 @@
               </a:spcBef>
               <a:defRPr sz="2200">
                 <a:solidFill>
-                  <a:srgbClr val="A8B0B9"/>
-                </a:solidFill>
-                <a:latin typeface="Google Sans"/>
+                  <a:srgbClr val="444746"/>
+                </a:solidFill>
+                <a:latin typeface="Roboto"/>
               </a:defRPr>
             </a:pPr>
             <a:r>
@@ -6169,9 +5130,9 @@
               </a:spcBef>
               <a:defRPr sz="2200">
                 <a:solidFill>
-                  <a:srgbClr val="A8B0B9"/>
-                </a:solidFill>
-                <a:latin typeface="Google Sans"/>
+                  <a:srgbClr val="444746"/>
+                </a:solidFill>
+                <a:latin typeface="Roboto"/>
               </a:defRPr>
             </a:pPr>
             <a:r>

</xml_diff>